<commit_message>
fix: print AuthKEM PRK_out only in DEBUG builds; repo setup docs
- edhoc-authkem mains print PRK_out (and its xor) only with DEBUG=1,
  so the session secret no longer reaches the console in normal or
  production builds; run_pair.sh then reports prk=- (prk=match with
  DEBUG=1).
- Root README: EDHOC fork overview, hardware, setup routes A/B.
- Slides: private repository URL and tag edhoc-course-v1; prk=match
  described as a DEBUG=1 result.
</commit_message>
<xml_diff>
--- a/fpga/sw/export/docs/slides/01_EDHOC_SoC_on_Arty_A7-100T.pptx
+++ b/fpga/sw/export/docs/slides/01_EDHOC_SoC_on_Arty_A7-100T.pptx
@@ -10897,7 +10897,7 @@
                 </a:solidFill>
                 <a:latin typeface="Consolas"/>
               </a:rPr>
-              <a:t>git clone [GitHub URL] chipyard</a:t>
+              <a:t>git clone git@github.com:Khaiduy/chipyard-edhoc.git chipyard</a:t>
             </a:r>
           </a:p>
           <a:p>
@@ -10929,7 +10929,7 @@
                 </a:solidFill>
                 <a:latin typeface="Consolas"/>
               </a:rPr>
-              <a:t>git checkout [revision]          # the revision these slides describe</a:t>
+              <a:t>git checkout edhoc-course-v1     # the revision these slides describe</a:t>
             </a:r>
           </a:p>
         </p:txBody>
@@ -11253,6 +11253,41 @@
             <a:spAutoFit/>
           </a:bodyPr>
           <a:lstStyle/>
+          <a:p>
+            <a:pPr marL="256032" indent="-219456">
+              <a:spcAft>
+                <a:spcPts val="400"/>
+              </a:spcAft>
+              <a:buChar char="•"/>
+            </a:pPr>
+            <a:r>
+              <a:rPr sz="1700" b="0">
+                <a:solidFill>
+                  <a:srgbClr val="000000"/>
+                </a:solidFill>
+                <a:latin typeface="Times New Roman"/>
+              </a:rPr>
+              <a:t>The repository is </a:t>
+            </a:r>
+            <a:r>
+              <a:rPr sz="1700" b="1">
+                <a:solidFill>
+                  <a:srgbClr val="000000"/>
+                </a:solidFill>
+                <a:latin typeface="Times New Roman"/>
+              </a:rPr>
+              <a:t>private</a:t>
+            </a:r>
+            <a:r>
+              <a:rPr sz="1700" b="0">
+                <a:solidFill>
+                  <a:srgbClr val="000000"/>
+                </a:solidFill>
+                <a:latin typeface="Times New Roman"/>
+              </a:rPr>
+              <a:t>: ask the author to add your GitHub account, then clone with your own SSH key.</a:t>
+            </a:r>
+          </a:p>
           <a:p>
             <a:pPr marL="256032" indent="-219456">
               <a:spcAft>
@@ -40141,7 +40176,7 @@
                 </a:solidFill>
                 <a:latin typeface="Times New Roman"/>
               </a:rPr>
-              <a:t>Repository: [GitHub URL]   ·   all paths are relative to chipyard-1.11.0/</a:t>
+              <a:t>Repository: github.com/Khaiduy/chipyard-edhoc (private: ask the author for access)   ·   paths are relative to its root</a:t>
             </a:r>
           </a:p>
         </p:txBody>

</xml_diff>

<commit_message>
fix: SD late write reply, sector retry, production+DEBUG guard
- sd_card.c: read the write data response as Linux mmc_spi does (find
  the start bit in 32 bits): one card sends it a byte late, which was
  reported as a failed write. Each sector is retried up to 3 times and
  every failed try prints its reason.
- PROFILE=production with DEBUG=1 is refused at build time (debug
  builds print every key).
- sha256/sha384_update: no memcpy from NULL on zero-length input.
- wolfCrypt compiled with -fwrapv (sp_c64.c relies on signed wrap).
- Slides: course name, author, date; SD bug 3; read-back caveat;
  measured UART link speed; build sizes of this revision.
</commit_message>
<xml_diff>
--- a/fpga/sw/export/docs/slides/01_EDHOC_SoC_on_Arty_A7-100T.pptx
+++ b/fpga/sw/export/docs/slides/01_EDHOC_SoC_on_Arty_A7-100T.pptx
@@ -9729,7 +9729,7 @@
                           </a:solidFill>
                           <a:latin typeface="Times New Roman"/>
                         </a:rPr>
-                        <a:t>wired UART1 link on PMOD JB instead of the radio</a:t>
+                        <a:t>wired UART1 link on PMOD JB (GND, TX↔RX crossed); works, but slower than the radio</a:t>
                       </a:r>
                     </a:p>
                   </a:txBody>
@@ -15042,7 +15042,7 @@
                 </a:solidFill>
                 <a:latin typeface="Times New Roman"/>
               </a:rPr>
-              <a:t>Smallest build (suite 4, method 3) needs ≈ 32.3 KB with its stack: only method 3 of suites 0 / 1 / 4 fits 32 KiB, and barely.</a:t>
+              <a:t>Smallest build (suite 4, method 3) needs ≈ 32.4 KB with its stack: only method 3 of suites 0 / 1 / 4 fits 32 KiB, and barely.</a:t>
             </a:r>
           </a:p>
           <a:p>
@@ -39316,7 +39316,7 @@
                 <a:latin typeface="Times New Roman"/>
                 <a:ea typeface="DejaVu Sans"/>
               </a:rPr>
-              <a:t>[YYYY/MM]</a:t>
+              <a:t>2026/12</a:t>
             </a:r>
             <a:endParaRPr lang="en-US" sz="3200" b="0" strike="noStrike" spc="-1" dirty="0">
               <a:latin typeface="Arial"/>
@@ -39480,7 +39480,7 @@
                 <a:latin typeface="Times New Roman"/>
                 <a:ea typeface="DejaVu Sans"/>
               </a:rPr>
-              <a:t>[YYYY/MM]</a:t>
+              <a:t>2026/12</a:t>
             </a:r>
             <a:endParaRPr lang="en-US" sz="3200" b="0" strike="noStrike" spc="-1" dirty="0">
               <a:latin typeface="Arial"/>
@@ -39582,7 +39582,7 @@
                 <a:latin typeface="Times New Roman"/>
                 <a:ea typeface="DejaVu Sans"/>
               </a:rPr>
-              <a:t>[Course name]</a:t>
+              <a:t>EDHOC on a Rocket RV64 SoC</a:t>
             </a:r>
             <a:r>
               <a:rPr lang="en-US" sz="4800" spc="-1" dirty="0">
@@ -39807,7 +39807,7 @@
                 <a:latin typeface="Times New Roman" panose="02020603050405020304" pitchFamily="18" charset="0"/>
                 <a:cs typeface="Times New Roman" panose="02020603050405020304" pitchFamily="18" charset="0"/>
               </a:rPr>
-              <a:t>[Author]</a:t>
+              <a:t>Khai-Duy Nguyen</a:t>
             </a:r>
           </a:p>
         </p:txBody>

</xml_diff>

<commit_message>
docs: setup figures from product images; PmodMicroSD naming
</commit_message>
<xml_diff>
--- a/fpga/sw/export/docs/slides/01_EDHOC_SoC_on_Arty_A7-100T.pptx
+++ b/fpga/sw/export/docs/slides/01_EDHOC_SoC_on_Arty_A7-100T.pptx
@@ -9482,7 +9482,7 @@
                           </a:solidFill>
                           <a:latin typeface="Times New Roman"/>
                         </a:rPr>
-                        <a:t>microSD PMOD adapter (PmodSD) + microSD card</a:t>
+                        <a:t>Digilent PmodMicroSD + microSD card</a:t>
                       </a:r>
                     </a:p>
                   </a:txBody>
@@ -9949,8 +9949,8 @@
         </p:blipFill>
         <p:spPr>
           <a:xfrm>
-            <a:off x="822960" y="822960"/>
-            <a:ext cx="9326880" cy="5486400"/>
+            <a:off x="2103120" y="822960"/>
+            <a:ext cx="7997125" cy="5486400"/>
           </a:xfrm>
           <a:prstGeom prst="rect">
             <a:avLst/>
@@ -9991,7 +9991,7 @@
                 </a:solidFill>
                 <a:latin typeface="Times New Roman"/>
               </a:rPr>
-              <a:t>Same wiring on both boards; the 3 UART wires on JB are optional (TRANSPORT=uart). Pin by pin: section 4 (2/8). Arty A7-35 shown; the A7-100T looks the same.</a:t>
+              <a:t>Same wiring on both boards; the 3 UART wires on JB are optional (TRANSPORT=uart). Pin by pin: section 4 (2/8).</a:t>
             </a:r>
           </a:p>
         </p:txBody>
@@ -17283,70 +17283,65 @@
           </a:p>
         </p:txBody>
       </p:sp>
+      <p:pic>
+        <p:nvPicPr>
+          <p:cNvPr id="84" name="Picture 83" descr="setup_two_boards.png"/>
+          <p:cNvPicPr>
+            <a:picLocks noChangeAspect="1"/>
+          </p:cNvPicPr>
+          <p:nvPr/>
+        </p:nvPicPr>
+        <p:blipFill>
+          <a:blip r:embed="rId3"/>
+          <a:stretch>
+            <a:fillRect/>
+          </a:stretch>
+        </p:blipFill>
+        <p:spPr>
+          <a:xfrm>
+            <a:off x="6400800" y="5257800"/>
+            <a:ext cx="1732711" cy="1188720"/>
+          </a:xfrm>
+          <a:prstGeom prst="rect">
+            <a:avLst/>
+          </a:prstGeom>
+        </p:spPr>
+      </p:pic>
       <p:sp>
         <p:nvSpPr>
-          <p:cNvPr id="84" name="Rectangle 83"/>
-          <p:cNvSpPr/>
+          <p:cNvPr id="85" name="TextBox 84"/>
+          <p:cNvSpPr txBox="1"/>
           <p:nvPr/>
         </p:nvSpPr>
         <p:spPr>
           <a:xfrm>
-            <a:off x="6400800" y="5349240"/>
-            <a:ext cx="5394960" cy="1097280"/>
+            <a:off x="8229600" y="5577840"/>
+            <a:ext cx="3657600" cy="548640"/>
           </a:xfrm>
           <a:prstGeom prst="rect">
             <a:avLst/>
           </a:prstGeom>
-          <a:solidFill>
-            <a:srgbClr val="E7E6E6"/>
-          </a:solidFill>
-          <a:ln>
-            <a:solidFill>
-              <a:srgbClr val="808080"/>
-            </a:solidFill>
-            <a:prstDash val="dash"/>
-          </a:ln>
-          <a:effectLst/>
+          <a:noFill/>
         </p:spPr>
-        <p:style>
-          <a:lnRef idx="1">
-            <a:schemeClr val="accent1"/>
-          </a:lnRef>
-          <a:fillRef idx="3">
-            <a:schemeClr val="accent1"/>
-          </a:fillRef>
-          <a:effectRef idx="2">
-            <a:schemeClr val="accent1"/>
-          </a:effectRef>
-          <a:fontRef idx="minor">
-            <a:schemeClr val="lt1"/>
-          </a:fontRef>
-        </p:style>
         <p:txBody>
-          <a:bodyPr rtlCol="0" anchor="ctr" wrap="square"/>
+          <a:bodyPr wrap="square" anchor="t">
+            <a:spAutoFit/>
+          </a:bodyPr>
           <a:lstStyle/>
           <a:p>
-            <a:pPr algn="ctr"/>
-            <a:r>
-              <a:rPr sz="1600" b="1">
+            <a:pPr>
+              <a:spcAft>
+                <a:spcPts val="400"/>
+              </a:spcAft>
+            </a:pPr>
+            <a:r>
+              <a:rPr sz="1400" b="0">
                 <a:solidFill>
                   <a:srgbClr val="808080"/>
                 </a:solidFill>
                 <a:latin typeface="Times New Roman"/>
               </a:rPr>
-              <a:t>PHOTO</a:t>
-            </a:r>
-          </a:p>
-          <a:p>
-            <a:pPr algn="ctr"/>
-            <a:r>
-              <a:rPr sz="1600" b="0">
-                <a:solidFill>
-                  <a:srgbClr val="808080"/>
-                </a:solidFill>
-                <a:latin typeface="Times New Roman"/>
-              </a:rPr>
-              <a:t>both boards wired: JA SD, JC radio, JD JTAG cable</a:t>
+              <a:t>Full-size picture: section 1, (3/8).</a:t>
             </a:r>
           </a:p>
         </p:txBody>
@@ -23372,7 +23367,7 @@
                           </a:solidFill>
                           <a:latin typeface="Times New Roman"/>
                         </a:rPr>
-                        <a:t>microSD (PmodSD)</a:t>
+                        <a:t>PmodMicroSD</a:t>
                       </a:r>
                     </a:p>
                   </a:txBody>
@@ -23718,7 +23713,7 @@
         <p:spPr>
           <a:xfrm>
             <a:off x="1371600" y="4023360"/>
-            <a:ext cx="3210016" cy="2468880"/>
+            <a:ext cx="2244436" cy="2468880"/>
           </a:xfrm>
           <a:prstGeom prst="rect">
             <a:avLst/>
@@ -26500,7 +26495,7 @@
                           </a:solidFill>
                           <a:latin typeface="Times New Roman"/>
                         </a:rPr>
-                        <a:t>PmodSD</a:t>
+                        <a:t>PmodMicroSD</a:t>
                       </a:r>
                     </a:p>
                   </a:txBody>
@@ -27020,70 +27015,65 @@
           </a:p>
         </p:txBody>
       </p:sp>
+      <p:pic>
+        <p:nvPicPr>
+          <p:cNvPr id="66" name="Picture 65" descr="pmodmicrosd-top.png"/>
+          <p:cNvPicPr>
+            <a:picLocks noChangeAspect="1"/>
+          </p:cNvPicPr>
+          <p:nvPr/>
+        </p:nvPicPr>
+        <p:blipFill>
+          <a:blip r:embed="rId3"/>
+          <a:stretch>
+            <a:fillRect/>
+          </a:stretch>
+        </p:blipFill>
+        <p:spPr>
+          <a:xfrm>
+            <a:off x="365760" y="5532120"/>
+            <a:ext cx="914400" cy="914400"/>
+          </a:xfrm>
+          <a:prstGeom prst="rect">
+            <a:avLst/>
+          </a:prstGeom>
+        </p:spPr>
+      </p:pic>
       <p:sp>
         <p:nvSpPr>
-          <p:cNvPr id="66" name="Rectangle 65"/>
-          <p:cNvSpPr/>
+          <p:cNvPr id="67" name="TextBox 66"/>
+          <p:cNvSpPr txBox="1"/>
           <p:nvPr/>
         </p:nvSpPr>
         <p:spPr>
           <a:xfrm>
-            <a:off x="365760" y="5623560"/>
-            <a:ext cx="6400800" cy="777240"/>
+            <a:off x="1371600" y="5760720"/>
+            <a:ext cx="5394960" cy="457200"/>
           </a:xfrm>
           <a:prstGeom prst="rect">
             <a:avLst/>
           </a:prstGeom>
-          <a:solidFill>
-            <a:srgbClr val="E7E6E6"/>
-          </a:solidFill>
-          <a:ln>
-            <a:solidFill>
-              <a:srgbClr val="808080"/>
-            </a:solidFill>
-            <a:prstDash val="dash"/>
-          </a:ln>
-          <a:effectLst/>
+          <a:noFill/>
         </p:spPr>
-        <p:style>
-          <a:lnRef idx="1">
-            <a:schemeClr val="accent1"/>
-          </a:lnRef>
-          <a:fillRef idx="3">
-            <a:schemeClr val="accent1"/>
-          </a:fillRef>
-          <a:effectRef idx="2">
-            <a:schemeClr val="accent1"/>
-          </a:effectRef>
-          <a:fontRef idx="minor">
-            <a:schemeClr val="lt1"/>
-          </a:fontRef>
-        </p:style>
         <p:txBody>
-          <a:bodyPr rtlCol="0" anchor="ctr" wrap="square"/>
+          <a:bodyPr wrap="square" anchor="t">
+            <a:spAutoFit/>
+          </a:bodyPr>
           <a:lstStyle/>
           <a:p>
-            <a:pPr algn="ctr"/>
-            <a:r>
-              <a:rPr sz="1600" b="1">
+            <a:pPr>
+              <a:spcAft>
+                <a:spcPts val="400"/>
+              </a:spcAft>
+            </a:pPr>
+            <a:r>
+              <a:rPr sz="1300" b="0">
                 <a:solidFill>
                   <a:srgbClr val="808080"/>
                 </a:solidFill>
                 <a:latin typeface="Times New Roman"/>
               </a:rPr>
-              <a:t>PHOTO</a:t>
-            </a:r>
-          </a:p>
-          <a:p>
-            <a:pPr algn="ctr"/>
-            <a:r>
-              <a:rPr sz="1600" b="0">
-                <a:solidFill>
-                  <a:srgbClr val="808080"/>
-                </a:solidFill>
-                <a:latin typeface="Times New Roman"/>
-              </a:rPr>
-              <a:t>PmodSD with microSD card on JA</a:t>
+              <a:t>PmodMicroSD (pin 1 = CS, top); image: Digilent Inc.</a:t>
             </a:r>
           </a:p>
         </p:txBody>
@@ -27657,70 +27647,65 @@
           </a:p>
         </p:txBody>
       </p:sp>
+      <p:pic>
+        <p:nvPicPr>
+          <p:cNvPr id="66" name="Picture 65" descr="mrf24J40.jpeg"/>
+          <p:cNvPicPr>
+            <a:picLocks noChangeAspect="1"/>
+          </p:cNvPicPr>
+          <p:nvPr/>
+        </p:nvPicPr>
+        <p:blipFill>
+          <a:blip r:embed="rId3"/>
+          <a:stretch>
+            <a:fillRect/>
+          </a:stretch>
+        </p:blipFill>
+        <p:spPr>
+          <a:xfrm>
+            <a:off x="365760" y="4152761"/>
+            <a:ext cx="960120" cy="960120"/>
+          </a:xfrm>
+          <a:prstGeom prst="rect">
+            <a:avLst/>
+          </a:prstGeom>
+        </p:spPr>
+      </p:pic>
       <p:sp>
         <p:nvSpPr>
-          <p:cNvPr id="66" name="Rectangle 65"/>
-          <p:cNvSpPr/>
+          <p:cNvPr id="67" name="TextBox 66"/>
+          <p:cNvSpPr txBox="1"/>
           <p:nvPr/>
         </p:nvSpPr>
         <p:spPr>
           <a:xfrm>
-            <a:off x="365760" y="4152761"/>
-            <a:ext cx="6035040" cy="960120"/>
+            <a:off x="1463040" y="4427081"/>
+            <a:ext cx="4937760" cy="457200"/>
           </a:xfrm>
           <a:prstGeom prst="rect">
             <a:avLst/>
           </a:prstGeom>
-          <a:solidFill>
-            <a:srgbClr val="E7E6E6"/>
-          </a:solidFill>
-          <a:ln>
-            <a:solidFill>
-              <a:srgbClr val="808080"/>
-            </a:solidFill>
-            <a:prstDash val="dash"/>
-          </a:ln>
-          <a:effectLst/>
+          <a:noFill/>
         </p:spPr>
-        <p:style>
-          <a:lnRef idx="1">
-            <a:schemeClr val="accent1"/>
-          </a:lnRef>
-          <a:fillRef idx="3">
-            <a:schemeClr val="accent1"/>
-          </a:fillRef>
-          <a:effectRef idx="2">
-            <a:schemeClr val="accent1"/>
-          </a:effectRef>
-          <a:fontRef idx="minor">
-            <a:schemeClr val="lt1"/>
-          </a:fontRef>
-        </p:style>
         <p:txBody>
-          <a:bodyPr rtlCol="0" anchor="ctr" wrap="square"/>
+          <a:bodyPr wrap="square" anchor="t">
+            <a:spAutoFit/>
+          </a:bodyPr>
           <a:lstStyle/>
           <a:p>
-            <a:pPr algn="ctr"/>
-            <a:r>
-              <a:rPr sz="1600" b="1">
+            <a:pPr>
+              <a:spcAft>
+                <a:spcPts val="400"/>
+              </a:spcAft>
+            </a:pPr>
+            <a:r>
+              <a:rPr sz="1300" b="0">
                 <a:solidFill>
                   <a:srgbClr val="808080"/>
                 </a:solidFill>
                 <a:latin typeface="Times New Roman"/>
               </a:rPr>
-              <a:t>PHOTO</a:t>
-            </a:r>
-          </a:p>
-          <a:p>
-            <a:pPr algn="ctr"/>
-            <a:r>
-              <a:rPr sz="1600" b="0">
-                <a:solidFill>
-                  <a:srgbClr val="808080"/>
-                </a:solidFill>
-                <a:latin typeface="Times New Roman"/>
-              </a:rPr>
-              <a:t>MRF24J40MA module on PMOD JC</a:t>
+              <a:t>MRF24J40MA, on a PMOD adapter on JC; image: Microchip Technology.</a:t>
             </a:r>
           </a:p>
         </p:txBody>
@@ -36884,74 +36869,30 @@
           </a:p>
         </p:txBody>
       </p:sp>
-      <p:sp>
-        <p:nvSpPr>
-          <p:cNvPr id="66" name="Rectangle 65"/>
-          <p:cNvSpPr/>
+      <p:pic>
+        <p:nvPicPr>
+          <p:cNvPr id="66" name="Picture 65" descr="pmodmicrosd-top.png"/>
+          <p:cNvPicPr>
+            <a:picLocks noChangeAspect="1"/>
+          </p:cNvPicPr>
           <p:nvPr/>
-        </p:nvSpPr>
+        </p:nvPicPr>
+        <p:blipFill>
+          <a:blip r:embed="rId3"/>
+          <a:stretch>
+            <a:fillRect/>
+          </a:stretch>
+        </p:blipFill>
         <p:spPr>
           <a:xfrm>
-            <a:off x="8046720" y="1994916"/>
-            <a:ext cx="3931920" cy="1828800"/>
+            <a:off x="8778240" y="1994916"/>
+            <a:ext cx="1828800" cy="1828800"/>
           </a:xfrm>
           <a:prstGeom prst="rect">
             <a:avLst/>
           </a:prstGeom>
-          <a:solidFill>
-            <a:srgbClr val="E7E6E6"/>
-          </a:solidFill>
-          <a:ln>
-            <a:solidFill>
-              <a:srgbClr val="808080"/>
-            </a:solidFill>
-            <a:prstDash val="dash"/>
-          </a:ln>
-          <a:effectLst/>
         </p:spPr>
-        <p:style>
-          <a:lnRef idx="1">
-            <a:schemeClr val="accent1"/>
-          </a:lnRef>
-          <a:fillRef idx="3">
-            <a:schemeClr val="accent1"/>
-          </a:fillRef>
-          <a:effectRef idx="2">
-            <a:schemeClr val="accent1"/>
-          </a:effectRef>
-          <a:fontRef idx="minor">
-            <a:schemeClr val="lt1"/>
-          </a:fontRef>
-        </p:style>
-        <p:txBody>
-          <a:bodyPr rtlCol="0" anchor="ctr" wrap="square"/>
-          <a:lstStyle/>
-          <a:p>
-            <a:pPr algn="ctr"/>
-            <a:r>
-              <a:rPr sz="1600" b="1">
-                <a:solidFill>
-                  <a:srgbClr val="808080"/>
-                </a:solidFill>
-                <a:latin typeface="Times New Roman"/>
-              </a:rPr>
-              <a:t>PHOTO</a:t>
-            </a:r>
-          </a:p>
-          <a:p>
-            <a:pPr algn="ctr"/>
-            <a:r>
-              <a:rPr sz="1600" b="0">
-                <a:solidFill>
-                  <a:srgbClr val="808080"/>
-                </a:solidFill>
-                <a:latin typeface="Times New Roman"/>
-              </a:rPr>
-              <a:t>microSD card in the PMOD JA slot</a:t>
-            </a:r>
-          </a:p>
-        </p:txBody>
-      </p:sp>
+      </p:pic>
     </p:spTree>
   </p:cSld>
   <p:clrMapOvr>

</xml_diff>

<commit_message>
docs: C232HM in the setup figure and on the JTAG slide
</commit_message>
<xml_diff>
--- a/fpga/sw/export/docs/slides/01_EDHOC_SoC_on_Arty_A7-100T.pptx
+++ b/fpga/sw/export/docs/slides/01_EDHOC_SoC_on_Arty_A7-100T.pptx
@@ -9949,8 +9949,8 @@
         </p:blipFill>
         <p:spPr>
           <a:xfrm>
-            <a:off x="2103120" y="822960"/>
-            <a:ext cx="7997125" cy="5486400"/>
+            <a:off x="2651760" y="804672"/>
+            <a:ext cx="6838122" cy="5486400"/>
           </a:xfrm>
           <a:prstGeom prst="rect">
             <a:avLst/>
@@ -17300,7 +17300,7 @@
         <p:spPr>
           <a:xfrm>
             <a:off x="6400800" y="5257800"/>
-            <a:ext cx="1732711" cy="1188720"/>
+            <a:ext cx="1481593" cy="1188720"/>
           </a:xfrm>
           <a:prstGeom prst="rect">
             <a:avLst/>
@@ -29315,70 +29315,65 @@
           </a:p>
         </p:txBody>
       </p:sp>
+      <p:pic>
+        <p:nvPicPr>
+          <p:cNvPr id="66" name="Picture 65" descr="C232HM.jpg"/>
+          <p:cNvPicPr>
+            <a:picLocks noChangeAspect="1"/>
+          </p:cNvPicPr>
+          <p:nvPr/>
+        </p:nvPicPr>
+        <p:blipFill>
+          <a:blip r:embed="rId3"/>
+          <a:stretch>
+            <a:fillRect/>
+          </a:stretch>
+        </p:blipFill>
+        <p:spPr>
+          <a:xfrm>
+            <a:off x="7223760" y="4800600"/>
+            <a:ext cx="1574684" cy="1463040"/>
+          </a:xfrm>
+          <a:prstGeom prst="rect">
+            <a:avLst/>
+          </a:prstGeom>
+        </p:spPr>
+      </p:pic>
       <p:sp>
         <p:nvSpPr>
-          <p:cNvPr id="66" name="Rectangle 65"/>
-          <p:cNvSpPr/>
+          <p:cNvPr id="67" name="TextBox 66"/>
+          <p:cNvSpPr txBox="1"/>
           <p:nvPr/>
         </p:nvSpPr>
         <p:spPr>
           <a:xfrm>
-            <a:off x="7223760" y="4846320"/>
-            <a:ext cx="4754880" cy="1554480"/>
+            <a:off x="8869680" y="5120640"/>
+            <a:ext cx="3108960" cy="914400"/>
           </a:xfrm>
           <a:prstGeom prst="rect">
             <a:avLst/>
           </a:prstGeom>
-          <a:solidFill>
-            <a:srgbClr val="E7E6E6"/>
-          </a:solidFill>
-          <a:ln>
-            <a:solidFill>
-              <a:srgbClr val="808080"/>
-            </a:solidFill>
-            <a:prstDash val="dash"/>
-          </a:ln>
-          <a:effectLst/>
+          <a:noFill/>
         </p:spPr>
-        <p:style>
-          <a:lnRef idx="1">
-            <a:schemeClr val="accent1"/>
-          </a:lnRef>
-          <a:fillRef idx="3">
-            <a:schemeClr val="accent1"/>
-          </a:fillRef>
-          <a:effectRef idx="2">
-            <a:schemeClr val="accent1"/>
-          </a:effectRef>
-          <a:fontRef idx="minor">
-            <a:schemeClr val="lt1"/>
-          </a:fontRef>
-        </p:style>
         <p:txBody>
-          <a:bodyPr rtlCol="0" anchor="ctr" wrap="square"/>
+          <a:bodyPr wrap="square" anchor="t">
+            <a:spAutoFit/>
+          </a:bodyPr>
           <a:lstStyle/>
           <a:p>
-            <a:pPr algn="ctr"/>
-            <a:r>
-              <a:rPr sz="1600" b="1">
+            <a:pPr>
+              <a:spcAft>
+                <a:spcPts val="400"/>
+              </a:spcAft>
+            </a:pPr>
+            <a:r>
+              <a:rPr sz="1300" b="0">
                 <a:solidFill>
                   <a:srgbClr val="808080"/>
                 </a:solidFill>
                 <a:latin typeface="Times New Roman"/>
               </a:rPr>
-              <a:t>PHOTO</a:t>
-            </a:r>
-          </a:p>
-          <a:p>
-            <a:pPr algn="ctr"/>
-            <a:r>
-              <a:rPr sz="1600" b="0">
-                <a:solidFill>
-                  <a:srgbClr val="808080"/>
-                </a:solidFill>
-                <a:latin typeface="Times New Roman"/>
-              </a:rPr>
-              <a:t>C232HM cable on PMOD JD</a:t>
+              <a:t>C232HM-DDHSL-0: flying leads to JD, USB to the PC; image: FTDI.</a:t>
             </a:r>
           </a:p>
         </p:txBody>

</xml_diff>

<commit_message>
docs: overlap-free setup figure, radio antenna pointing outwards
</commit_message>
<xml_diff>
--- a/fpga/sw/export/docs/slides/01_EDHOC_SoC_on_Arty_A7-100T.pptx
+++ b/fpga/sw/export/docs/slides/01_EDHOC_SoC_on_Arty_A7-100T.pptx
@@ -9950,7 +9950,7 @@
         <p:spPr>
           <a:xfrm>
             <a:off x="2651760" y="804672"/>
-            <a:ext cx="6838122" cy="5486400"/>
+            <a:ext cx="6692630" cy="5486400"/>
           </a:xfrm>
           <a:prstGeom prst="rect">
             <a:avLst/>
@@ -17300,7 +17300,7 @@
         <p:spPr>
           <a:xfrm>
             <a:off x="6400800" y="5257800"/>
-            <a:ext cx="1481593" cy="1188720"/>
+            <a:ext cx="1450070" cy="1188720"/>
           </a:xfrm>
           <a:prstGeom prst="rect">
             <a:avLst/>

</xml_diff>

<commit_message>
fix: length-checked SD verify, whole-run stack line; slide review fixes
</commit_message>
<xml_diff>
--- a/fpga/sw/export/docs/slides/01_EDHOC_SoC_on_Arty_A7-100T.pptx
+++ b/fpga/sw/export/docs/slides/01_EDHOC_SoC_on_Arty_A7-100T.pptx
@@ -3740,40 +3740,40 @@
                 <c:formatCode>General</c:formatCode>
                 <c:ptCount val="12"/>
                 <c:pt idx="0">
-                  <c:v>42291</c:v>
+                  <c:v>42505</c:v>
                 </c:pt>
                 <c:pt idx="1">
-                  <c:v>42291</c:v>
+                  <c:v>42505</c:v>
                 </c:pt>
                 <c:pt idx="2">
-                  <c:v>43739</c:v>
+                  <c:v>43977</c:v>
                 </c:pt>
                 <c:pt idx="3">
-                  <c:v>43739</c:v>
+                  <c:v>43977</c:v>
                 </c:pt>
                 <c:pt idx="4">
-                  <c:v>41653</c:v>
+                  <c:v>41863</c:v>
                 </c:pt>
                 <c:pt idx="5">
-                  <c:v>43365</c:v>
+                  <c:v>43603</c:v>
                 </c:pt>
                 <c:pt idx="6">
-                  <c:v>46361</c:v>
+                  <c:v>46595</c:v>
                 </c:pt>
                 <c:pt idx="7">
-                  <c:v>47391</c:v>
+                  <c:v>47673</c:v>
                 </c:pt>
                 <c:pt idx="8">
-                  <c:v>47913</c:v>
+                  <c:v>48209</c:v>
                 </c:pt>
                 <c:pt idx="9">
-                  <c:v>32712</c:v>
+                  <c:v>32718</c:v>
                 </c:pt>
                 <c:pt idx="10">
-                  <c:v>32876</c:v>
+                  <c:v>32878</c:v>
                 </c:pt>
                 <c:pt idx="11">
-                  <c:v>37637</c:v>
+                  <c:v>37663</c:v>
                 </c:pt>
               </c:numCache>
             </c:numRef>
@@ -15238,7 +15238,7 @@
                 </a:solidFill>
                 <a:latin typeface="Times New Roman"/>
               </a:rPr>
-              <a:t>; largest: suite 25 = 60,457 B, TBD3 = 61,445 B.</a:t>
+              <a:t>; largest: suite 25 = 60,753 B, TBD3 = 61,471 B.</a:t>
             </a:r>
           </a:p>
           <a:p>
@@ -15255,7 +15255,7 @@
                 </a:solidFill>
                 <a:latin typeface="Times New Roman"/>
               </a:rPr>
-              <a:t>Smallest build (suite 4, method 3) needs ≈ 32.4 KB with its stack: only method 3 of suites 0 / 1 / 4 fits 32 KiB, and barely.</a:t>
+              <a:t>32 KiB: only suite 4, method 3, initiator fits (32,539 B, 229 B spare); its responder is 69 B over, suites 0 / 1 method 3 141–437 B over.</a:t>
             </a:r>
           </a:p>
           <a:p>
@@ -15290,6 +15290,23 @@
                 <a:latin typeface="Times New Roman"/>
               </a:rPr>
               <a:t>The requirement says “minimum 32 KiB”, so 64 KiB is within it.</a:t>
+            </a:r>
+          </a:p>
+          <a:p>
+            <a:pPr marL="256032" indent="-219456">
+              <a:spcAft>
+                <a:spcPts val="400"/>
+              </a:spcAft>
+              <a:buChar char="•"/>
+            </a:pPr>
+            <a:r>
+              <a:rPr sz="1700" b="0">
+                <a:solidFill>
+                  <a:srgbClr val="000000"/>
+                </a:solidFill>
+                <a:latin typeface="Times New Roman"/>
+              </a:rPr>
+              <a:t>Build set: this revision, default flags (TRANSPORT=rf; no TIMING, DEBUG or APP options); per suite the build with the largest image + stack reserve.</a:t>
             </a:r>
           </a:p>
         </p:txBody>
@@ -21525,7 +21542,7 @@
                 </a:solidFill>
                 <a:latin typeface="Times New Roman"/>
               </a:rPr>
-              <a:t>Each list entry is one controller instance; the list index is the port number used by the overlays in section 3 (SPI0 → JA, SPI1 → JC).</a:t>
+              <a:t>Each list entry is one controller instance; the list index is the port number used by the overlays in section 4 (SPI0 → JA, SPI1 → JC).</a:t>
             </a:r>
           </a:p>
           <a:p>
@@ -22586,7 +22603,7 @@
                 </a:solidFill>
                 <a:latin typeface="Times New Roman"/>
               </a:rPr>
-              <a:t>During development we skip it: firmware is loaded over JTAG in seconds (section 5).</a:t>
+              <a:t>During development we skip it: firmware is loaded over JTAG in seconds (section 6).</a:t>
             </a:r>
           </a:p>
         </p:txBody>
@@ -28199,7 +28216,7 @@
                 </a:solidFill>
                 <a:latin typeface="Times New Roman"/>
               </a:rPr>
-              <a:t>Each board shows up as two ttyUSB devices; the console is interface 1 of the Digilent FTDI. Find it by serial number, because ttyUSB numbers change when Vivado or OpenOCD opens a port (section 5).</a:t>
+              <a:t>Each board shows up as two ttyUSB devices; the console is interface 1 of the Digilent FTDI. Find it by serial number, because ttyUSB numbers change when Vivado or OpenOCD opens a port (section 6).</a:t>
             </a:r>
           </a:p>
         </p:txBody>
@@ -30593,7 +30610,7 @@
                 </a:solidFill>
                 <a:latin typeface="Consolas"/>
               </a:rPr>
-              <a:t>echo $?                    # 0 = done; 2 = timing failed (a .bit is still written)</a:t>
+              <a:t>echo $?                    # 0 = make finished; nonzero = something failed: read the log</a:t>
             </a:r>
           </a:p>
         </p:txBody>
@@ -30782,7 +30799,7 @@
                 </a:solidFill>
                 <a:latin typeface="Times New Roman"/>
               </a:rPr>
-              <a:t> if timing fails, make stops with exit code 2 but still writes the </a:t>
+              <a:t> exit status 0 does not mean timing was met, and a failed flow may still leave a </a:t>
             </a:r>
             <a:r>
               <a:rPr sz="1800" b="0" i="1">
@@ -30800,7 +30817,7 @@
                 </a:solidFill>
                 <a:latin typeface="Times New Roman"/>
               </a:rPr>
-              <a:t> file. Always read </a:t>
+              <a:t>. Timing is decided only by </a:t>
             </a:r>
             <a:r>
               <a:rPr sz="1800" b="0" i="1">
@@ -30809,7 +30826,7 @@
                 </a:solidFill>
                 <a:latin typeface="Times New Roman"/>
               </a:rPr>
-              <a:t>timing.txt</a:t>
+              <a:t>report/timing.txt</a:t>
             </a:r>
             <a:r>
               <a:rPr sz="1800" b="0">
@@ -30818,7 +30835,7 @@
                 </a:solidFill>
                 <a:latin typeface="Times New Roman"/>
               </a:rPr>
-              <a:t> before using a new bitstream.</a:t>
+              <a:t>: read it before using a new bitstream.</a:t>
             </a:r>
           </a:p>
         </p:txBody>
@@ -33063,7 +33080,7 @@
                           </a:solidFill>
                           <a:latin typeface="Times New Roman"/>
                         </a:rPr>
-                        <a:t>exit status of make</a:t>
+                        <a:t>exit status of make, then the log</a:t>
                       </a:r>
                     </a:p>
                   </a:txBody>
@@ -33085,7 +33102,7 @@
                           </a:solidFill>
                           <a:latin typeface="Times New Roman"/>
                         </a:rPr>
-                        <a:t>0 (2 = timing failed, even though a .bit exists)</a:t>
+                        <a:t>0; nonzero = build failed</a:t>
                       </a:r>
                     </a:p>
                   </a:txBody>
@@ -34671,7 +34688,7 @@
         <p:spPr>
           <a:xfrm>
             <a:off x="365760" y="868680"/>
-            <a:ext cx="7315200" cy="1465123"/>
+            <a:ext cx="7315200" cy="1139631"/>
           </a:xfrm>
           <a:prstGeom prst="rect">
             <a:avLst/>
@@ -34706,13 +34723,13 @@
           <a:p>
             <a:pPr algn="l"/>
             <a:r>
-              <a:rPr sz="1165" b="1">
+              <a:rPr sz="1211" b="1">
                 <a:solidFill>
                   <a:srgbClr val="808080"/>
                 </a:solidFill>
                 <a:latin typeface="Consolas"/>
               </a:rPr>
-              <a:t>Run this</a:t>
+              <a:t>Run this — from the repository root</a:t>
             </a:r>
           </a:p>
           <a:p>
@@ -34722,7 +34739,7 @@
               </a:lnSpc>
             </a:pPr>
             <a:r>
-              <a:rPr sz="1165">
+              <a:rPr sz="1211">
                 <a:solidFill>
                   <a:srgbClr val="1F1F1F"/>
                 </a:solidFill>
@@ -34738,7 +34755,7 @@
               </a:lnSpc>
             </a:pPr>
             <a:r>
-              <a:rPr sz="1165">
+              <a:rPr sz="1211">
                 <a:solidFill>
                   <a:srgbClr val="1F1F1F"/>
                 </a:solidFill>
@@ -34754,13 +34771,13 @@
               </a:lnSpc>
             </a:pPr>
             <a:r>
-              <a:rPr sz="1165">
+              <a:rPr sz="1211">
                 <a:solidFill>
                   <a:srgbClr val="1F1F1F"/>
                 </a:solidFill>
                 <a:latin typeface="Consolas"/>
               </a:rPr>
-              <a:t>BOARD=initiator \</a:t>
+              <a:t>BOARD=initiator ../common/board/run_one.sh build/gpio_test.elf 5   # board A</a:t>
             </a:r>
           </a:p>
           <a:p>
@@ -34770,45 +34787,13 @@
               </a:lnSpc>
             </a:pPr>
             <a:r>
-              <a:rPr sz="1165">
+              <a:rPr sz="1211">
                 <a:solidFill>
                   <a:srgbClr val="1F1F1F"/>
                 </a:solidFill>
                 <a:latin typeface="Consolas"/>
               </a:rPr>
-              <a:t>  ../common/board/run_one.sh build/gpio_test.elf 5   # load, run, print console</a:t>
-            </a:r>
-          </a:p>
-          <a:p>
-            <a:pPr algn="l">
-              <a:lnSpc>
-                <a:spcPct val="100000"/>
-              </a:lnSpc>
-            </a:pPr>
-            <a:r>
-              <a:rPr sz="1165">
-                <a:solidFill>
-                  <a:srgbClr val="2E7D32"/>
-                </a:solidFill>
-                <a:latin typeface="Consolas"/>
-              </a:rPr>
-              <a:t># both boards at once (responder first):</a:t>
-            </a:r>
-          </a:p>
-          <a:p>
-            <a:pPr algn="l">
-              <a:lnSpc>
-                <a:spcPct val="100000"/>
-              </a:lnSpc>
-            </a:pPr>
-            <a:r>
-              <a:rPr sz="1165">
-                <a:solidFill>
-                  <a:srgbClr val="1F1F1F"/>
-                </a:solidFill>
-                <a:latin typeface="Consolas"/>
-              </a:rPr>
-              <a:t>../common/board/load_both.sh A.elf B.elf</a:t>
+              <a:t>BOARD=responder ../common/board/run_one.sh build/gpio_test.elf 5   # board B</a:t>
             </a:r>
           </a:p>
         </p:txBody>
@@ -34821,8 +34806,8 @@
         </p:nvSpPr>
         <p:spPr>
           <a:xfrm>
-            <a:off x="365760" y="2516683"/>
-            <a:ext cx="7315200" cy="1006856"/>
+            <a:off x="365760" y="2191191"/>
+            <a:ext cx="7315200" cy="1004809"/>
           </a:xfrm>
           <a:prstGeom prst="rect">
             <a:avLst/>
@@ -34857,13 +34842,13 @@
           <a:p>
             <a:pPr algn="l"/>
             <a:r>
-              <a:rPr sz="1300" b="1">
+              <a:rPr sz="1296" b="1">
                 <a:solidFill>
                   <a:srgbClr val="808080"/>
                 </a:solidFill>
                 <a:latin typeface="Consolas"/>
               </a:rPr>
-              <a:t>Run this — what run_one.sh does (simplified)</a:t>
+              <a:t>Simplified — what run_one.sh does ($SERIAL, $ELF are set by the script)</a:t>
             </a:r>
           </a:p>
           <a:p>
@@ -34873,7 +34858,7 @@
               </a:lnSpc>
             </a:pPr>
             <a:r>
-              <a:rPr sz="1300">
+              <a:rPr sz="1296">
                 <a:solidFill>
                   <a:srgbClr val="1F1F1F"/>
                 </a:solidFill>
@@ -34889,7 +34874,7 @@
               </a:lnSpc>
             </a:pPr>
             <a:r>
-              <a:rPr sz="1300">
+              <a:rPr sz="1296">
                 <a:solidFill>
                   <a:srgbClr val="1F1F1F"/>
                 </a:solidFill>
@@ -34905,7 +34890,7 @@
               </a:lnSpc>
             </a:pPr>
             <a:r>
-              <a:rPr sz="1300">
+              <a:rPr sz="1296">
                 <a:solidFill>
                   <a:srgbClr val="1F1F1F"/>
                 </a:solidFill>
@@ -34977,6 +34962,41 @@
                 </a:solidFill>
                 <a:latin typeface="Times New Roman"/>
               </a:rPr>
+              <a:t>Both boards at once (responder first): </a:t>
+            </a:r>
+            <a:r>
+              <a:rPr sz="1400" b="0">
+                <a:solidFill>
+                  <a:srgbClr val="8B1A1A"/>
+                </a:solidFill>
+                <a:latin typeface="Consolas"/>
+              </a:rPr>
+              <a:t>load_both.sh &lt;initiator.elf&gt; &lt;responder.elf&gt;</a:t>
+            </a:r>
+            <a:r>
+              <a:rPr sz="1600" b="0">
+                <a:solidFill>
+                  <a:srgbClr val="000000"/>
+                </a:solidFill>
+                <a:latin typeface="Times New Roman"/>
+              </a:rPr>
+              <a:t>, used from Lesson 3 on.</a:t>
+            </a:r>
+          </a:p>
+          <a:p>
+            <a:pPr marL="256032" indent="-219456">
+              <a:spcAft>
+                <a:spcPts val="400"/>
+              </a:spcAft>
+              <a:buChar char="•"/>
+            </a:pPr>
+            <a:r>
+              <a:rPr sz="1600" b="0">
+                <a:solidFill>
+                  <a:srgbClr val="000000"/>
+                </a:solidFill>
+                <a:latin typeface="Times New Roman"/>
+              </a:rPr>
               <a:t>Cable and console of each board come from </a:t>
             </a:r>
             <a:r>
@@ -35025,7 +35045,7 @@
         </p:nvSpPr>
         <p:spPr>
           <a:xfrm>
-            <a:off x="365760" y="3706418"/>
+            <a:off x="365760" y="3378880"/>
             <a:ext cx="7315200" cy="576553"/>
           </a:xfrm>
           <a:prstGeom prst="rect">
@@ -36475,7 +36495,7 @@
         <p:spPr>
           <a:xfrm>
             <a:off x="365760" y="868680"/>
-            <a:ext cx="11430000" cy="851916"/>
+            <a:ext cx="11430000" cy="1068832"/>
           </a:xfrm>
           <a:prstGeom prst="rect">
             <a:avLst/>
@@ -36516,7 +36536,7 @@
                 </a:solidFill>
                 <a:latin typeface="Consolas"/>
               </a:rPr>
-              <a:t>Run this</a:t>
+              <a:t>Run this — from the repository root; sdX = your card reader (lsblk)</a:t>
             </a:r>
           </a:p>
           <a:p>
@@ -36532,7 +36552,7 @@
                 </a:solidFill>
                 <a:latin typeface="Consolas"/>
               </a:rPr>
-              <a:t>sudo fpga/sw/export/tools/mksd.sh /dev/sdX            # once: partitions + FAT32</a:t>
+              <a:t>cd fpga/sw/export/tests &amp;&amp; make gpio_test      # -&gt; build/gpio_test.bin</a:t>
             </a:r>
           </a:p>
           <a:p>
@@ -36548,7 +36568,23 @@
                 </a:solidFill>
                 <a:latin typeface="Consolas"/>
               </a:rPr>
-              <a:t>sudo fpga/sw/export/common/board/sd_boot.sh build/app.bin sdX1   # firmware -&gt; LBA 2048</a:t>
+              <a:t>sudo ../tools/mksd.sh /dev/sdX                       # once; ERASES the card</a:t>
+            </a:r>
+          </a:p>
+          <a:p>
+            <a:pPr algn="l">
+              <a:lnSpc>
+                <a:spcPct val="100000"/>
+              </a:lnSpc>
+            </a:pPr>
+            <a:r>
+              <a:rPr sz="1400">
+                <a:solidFill>
+                  <a:srgbClr val="1F1F1F"/>
+                </a:solidFill>
+                <a:latin typeface="Consolas"/>
+              </a:rPr>
+              <a:t>sudo ../common/board/sd_boot.sh build/gpio_test.bin sdX1    # image -&gt; LBA 2048</a:t>
             </a:r>
           </a:p>
         </p:txBody>
@@ -36562,7 +36598,7 @@
           <p:nvPr/>
         </p:nvGraphicFramePr>
         <p:xfrm>
-          <a:off x="365760" y="1994916"/>
+          <a:off x="365760" y="2211832"/>
           <a:ext cx="7498080" cy="1828800"/>
         </p:xfrm>
         <a:graphic>
@@ -36880,7 +36916,7 @@
         </p:blipFill>
         <p:spPr>
           <a:xfrm>
-            <a:off x="8778240" y="1994916"/>
+            <a:off x="8778240" y="2211832"/>
             <a:ext cx="1828800" cy="1828800"/>
           </a:xfrm>
           <a:prstGeom prst="rect">
@@ -38998,7 +39034,7 @@
                 </a:solidFill>
                 <a:latin typeface="Times New Roman"/>
               </a:rPr>
-              <a:t>64 KiB because the largest EDHOC build needs 61.4 KB with its stack; 75 MHz because this implementation failed timing at 100 MHz and closes at 75 MHz.</a:t>
+              <a:t>64 KiB because the largest EDHOC build needs 61.5 KB with its stack; 75 MHz because this implementation failed timing at 100 MHz and closes at 75 MHz.</a:t>
             </a:r>
           </a:p>
           <a:p>

</xml_diff>

<commit_message>
docs: clone main directly, no course tag
</commit_message>
<xml_diff>
--- a/fpga/sw/export/docs/slides/01_EDHOC_SoC_on_Arty_A7-100T.pptx
+++ b/fpga/sw/export/docs/slides/01_EDHOC_SoC_on_Arty_A7-100T.pptx
@@ -9551,7 +9551,7 @@
                           </a:solidFill>
                           <a:latin typeface="Times New Roman"/>
                         </a:rPr>
-                        <a:t>MRF24J40MA 802.15.4 module on a PMOD adapter</a:t>
+                        <a:t>MRF24J40MA 802.15.4 module</a:t>
                       </a:r>
                     </a:p>
                   </a:txBody>
@@ -9595,7 +9595,7 @@
                           </a:solidFill>
                           <a:latin typeface="Times New Roman"/>
                         </a:rPr>
-                        <a:t>PMOD JC; a custom PCB: module pins to JC in section 4 (6/9)</a:t>
+                        <a:t>PMOD JC; module-to-JC signal wiring in section 4 (6/9)</a:t>
                       </a:r>
                     </a:p>
                   </a:txBody>
@@ -11054,7 +11054,7 @@
         <p:spPr>
           <a:xfrm>
             <a:off x="365760" y="868680"/>
-            <a:ext cx="11430000" cy="1097280"/>
+            <a:ext cx="11430000" cy="898397"/>
           </a:xfrm>
           <a:prstGeom prst="rect">
             <a:avLst/>
@@ -11089,7 +11089,7 @@
           <a:p>
             <a:pPr algn="l"/>
             <a:r>
-              <a:rPr sz="1475" b="1">
+              <a:rPr sz="1500" b="1">
                 <a:solidFill>
                   <a:srgbClr val="808080"/>
                 </a:solidFill>
@@ -11105,7 +11105,7 @@
               </a:lnSpc>
             </a:pPr>
             <a:r>
-              <a:rPr sz="1475">
+              <a:rPr sz="1500">
                 <a:solidFill>
                   <a:srgbClr val="1F1F1F"/>
                 </a:solidFill>
@@ -11121,29 +11121,13 @@
               </a:lnSpc>
             </a:pPr>
             <a:r>
-              <a:rPr sz="1475">
+              <a:rPr sz="1500">
                 <a:solidFill>
                   <a:srgbClr val="1F1F1F"/>
                 </a:solidFill>
                 <a:latin typeface="Consolas"/>
               </a:rPr>
               <a:t>cd chipyard</a:t>
-            </a:r>
-          </a:p>
-          <a:p>
-            <a:pPr algn="l">
-              <a:lnSpc>
-                <a:spcPct val="100000"/>
-              </a:lnSpc>
-            </a:pPr>
-            <a:r>
-              <a:rPr sz="1475">
-                <a:solidFill>
-                  <a:srgbClr val="1F1F1F"/>
-                </a:solidFill>
-                <a:latin typeface="Consolas"/>
-              </a:rPr>
-              <a:t>git checkout edhoc-course-v1     # the revision these slides describe</a:t>
             </a:r>
           </a:p>
         </p:txBody>
@@ -11157,7 +11141,7 @@
           <p:nvPr/>
         </p:nvGraphicFramePr>
         <p:xfrm>
-          <a:off x="365760" y="2240279"/>
+          <a:off x="365760" y="2041397"/>
           <a:ext cx="11430000" cy="2103120"/>
         </p:xfrm>
         <a:graphic>
@@ -28903,7 +28887,7 @@
                 </a:solidFill>
                 <a:latin typeface="Times New Roman"/>
               </a:rPr>
-              <a:t>The course uses a small custom PCB that wires exactly this. Any adapter works if it does the same; check the module pins against the MRF24J40MA data sheet.</a:t>
+              <a:t>Connect the module signals to the JC pins shown here; check the module pin numbers against the MRF24J40MA data sheet.</a:t>
             </a:r>
           </a:p>
           <a:p>
@@ -33601,7 +33585,7 @@
         <p:spPr>
           <a:xfrm>
             <a:off x="365760" y="2331720"/>
-            <a:ext cx="7498079" cy="1980540"/>
+            <a:ext cx="7498079" cy="2215388"/>
           </a:xfrm>
           <a:prstGeom prst="rect">
             <a:avLst/>
@@ -33640,13 +33624,13 @@
               </a:lnSpc>
             </a:pPr>
             <a:r>
-              <a:rPr sz="1276">
+              <a:rPr sz="1300">
                 <a:solidFill>
                   <a:srgbClr val="1F1F1F"/>
                 </a:solidFill>
                 <a:latin typeface="Consolas"/>
               </a:rPr>
-              <a:t>open_checkpoint obj/post_opt.dcp</a:t>
+              <a:t>open_checkpoint post_opt.dcp</a:t>
             </a:r>
           </a:p>
           <a:p>
@@ -33656,7 +33640,7 @@
               </a:lnSpc>
             </a:pPr>
             <a:r>
-              <a:rPr sz="1276">
+              <a:rPr sz="1300">
                 <a:solidFill>
                   <a:srgbClr val="1F1F1F"/>
                 </a:solidFill>
@@ -33672,7 +33656,7 @@
               </a:lnSpc>
             </a:pPr>
             <a:r>
-              <a:rPr sz="1276">
+              <a:rPr sz="1300">
                 <a:solidFill>
                   <a:srgbClr val="1F1F1F"/>
                 </a:solidFill>
@@ -33688,7 +33672,7 @@
               </a:lnSpc>
             </a:pPr>
             <a:r>
-              <a:rPr sz="1276">
+              <a:rPr sz="1300">
                 <a:solidFill>
                   <a:srgbClr val="1F1F1F"/>
                 </a:solidFill>
@@ -33704,7 +33688,7 @@
               </a:lnSpc>
             </a:pPr>
             <a:r>
-              <a:rPr sz="1276">
+              <a:rPr sz="1300">
                 <a:solidFill>
                   <a:srgbClr val="1F1F1F"/>
                 </a:solidFill>
@@ -33720,7 +33704,7 @@
               </a:lnSpc>
             </a:pPr>
             <a:r>
-              <a:rPr sz="1276">
+              <a:rPr sz="1300">
                 <a:solidFill>
                   <a:srgbClr val="1F1F1F"/>
                 </a:solidFill>
@@ -33736,7 +33720,7 @@
               </a:lnSpc>
             </a:pPr>
             <a:r>
-              <a:rPr sz="1276">
+              <a:rPr sz="1300">
                 <a:solidFill>
                   <a:srgbClr val="1F1F1F"/>
                 </a:solidFill>
@@ -33752,13 +33736,13 @@
               </a:lnSpc>
             </a:pPr>
             <a:r>
-              <a:rPr sz="1276">
+              <a:rPr sz="1300">
                 <a:solidFill>
                   <a:srgbClr val="1F1F1F"/>
                 </a:solidFill>
                 <a:latin typeface="Consolas"/>
               </a:rPr>
-              <a:t>report_timing_summary -file timing.txt        ;# expect WNS &gt;= 0, WHS &gt;= 0</a:t>
+              <a:t>file mkdir report</a:t>
             </a:r>
           </a:p>
           <a:p>
@@ -33768,7 +33752,23 @@
               </a:lnSpc>
             </a:pPr>
             <a:r>
-              <a:rPr sz="1276">
+              <a:rPr sz="1300">
+                <a:solidFill>
+                  <a:srgbClr val="1F1F1F"/>
+                </a:solidFill>
+                <a:latin typeface="Consolas"/>
+              </a:rPr>
+              <a:t>report_timing_summary -file report/timing.txt ;# check WNS and WHS &gt;= 0</a:t>
+            </a:r>
+          </a:p>
+          <a:p>
+            <a:pPr algn="l">
+              <a:lnSpc>
+                <a:spcPct val="100000"/>
+              </a:lnSpc>
+            </a:pPr>
+            <a:r>
+              <a:rPr sz="1300">
                 <a:solidFill>
                   <a:srgbClr val="1F1F1F"/>
                 </a:solidFill>
@@ -33831,7 +33831,7 @@
                 </a:solidFill>
                 <a:latin typeface="Times New Roman"/>
               </a:rPr>
-              <a:t>Do not add extra clock uncertainty to “help” placement: it makes WNS worse.</a:t>
+              <a:t>Extra clock uncertainty did not improve the measured implementation; do not assume it will repair a timing failure.</a:t>
             </a:r>
           </a:p>
           <a:p>
@@ -37969,7 +37969,7 @@
                 </a:solidFill>
                 <a:latin typeface="Times New Roman"/>
               </a:rPr>
-              <a:t>No card reader? </a:t>
+              <a:t>No card reader? First format the card with </a:t>
             </a:r>
             <a:r>
               <a:rPr sz="1500" b="0" i="1">
@@ -37978,7 +37978,7 @@
                 </a:solidFill>
                 <a:latin typeface="Times New Roman"/>
               </a:rPr>
-              <a:t>tests/sd_prep</a:t>
+              <a:t>sd_prep</a:t>
             </a:r>
             <a:r>
               <a:rPr sz="1500" b="0">
@@ -37987,7 +37987,25 @@
                 </a:solidFill>
                 <a:latin typeface="Times New Roman"/>
               </a:rPr>
-              <a:t> formats the card from the board over JTAG; </a:t>
+              <a:t> (Lesson 5). In </a:t>
+            </a:r>
+            <a:r>
+              <a:rPr sz="1500" b="0" i="1">
+                <a:solidFill>
+                  <a:srgbClr val="000000"/>
+                </a:solidFill>
+                <a:latin typeface="Times New Roman"/>
+              </a:rPr>
+              <a:t>tests/</a:t>
+            </a:r>
+            <a:r>
+              <a:rPr sz="1500" b="0">
+                <a:solidFill>
+                  <a:srgbClr val="000000"/>
+                </a:solidFill>
+                <a:latin typeface="Times New Roman"/>
+              </a:rPr>
+              <a:t>: </a:t>
             </a:r>
             <a:r>
               <a:rPr sz="1300" b="0">
@@ -37996,7 +38014,7 @@
                 </a:solidFill>
                 <a:latin typeface="Consolas"/>
               </a:rPr>
-              <a:t>cp build/gpio_test.bin build/boot.bin; make -B sd_prep EXTRA_CFLAGS=-DSD_PREP_BOOT</a:t>
+              <a:t>cp build/gpio_test.bin build/boot.bin</a:t>
             </a:r>
             <a:r>
               <a:rPr sz="1500" b="0">
@@ -38005,7 +38023,43 @@
                 </a:solidFill>
                 <a:latin typeface="Times New Roman"/>
               </a:rPr>
-              <a:t> also writes the image to LBA 2048.</a:t>
+              <a:t>, then </a:t>
+            </a:r>
+            <a:r>
+              <a:rPr sz="1300" b="0">
+                <a:solidFill>
+                  <a:srgbClr val="8B1A1A"/>
+                </a:solidFill>
+                <a:latin typeface="Consolas"/>
+              </a:rPr>
+              <a:t>make -B sd_prep EXTRA_CFLAGS=-DSD_PREP_BOOT</a:t>
+            </a:r>
+            <a:r>
+              <a:rPr sz="1500" b="0">
+                <a:solidFill>
+                  <a:srgbClr val="000000"/>
+                </a:solidFill>
+                <a:latin typeface="Times New Roman"/>
+              </a:rPr>
+              <a:t>. Load it with </a:t>
+            </a:r>
+            <a:r>
+              <a:rPr sz="1300" b="0">
+                <a:solidFill>
+                  <a:srgbClr val="8B1A1A"/>
+                </a:solidFill>
+                <a:latin typeface="Consolas"/>
+              </a:rPr>
+              <a:t>BOARD=initiator ../common/board/run_one.sh build/sd_prep.elf 30</a:t>
+            </a:r>
+            <a:r>
+              <a:rPr sz="1500" b="0">
+                <a:solidFill>
+                  <a:srgbClr val="000000"/>
+                </a:solidFill>
+                <a:latin typeface="Times New Roman"/>
+              </a:rPr>
+              <a:t>, then press RESET.</a:t>
             </a:r>
           </a:p>
         </p:txBody>

</xml_diff>

<commit_message>
docs: fix setup steps found by a copy-paste run
Drop ./scripts/init-fpga.sh (not in Chipyard 1.11); run build-setup.sh
with --skip-marshal --skip-firesim; venv + setuptools<81 for the host
tools; say where each AuthKEM suite builds; boards.env must be edited;
time and disk estimate for route A; fix a section reference.
</commit_message>
<xml_diff>
--- a/fpga/sw/export/docs/slides/01_EDHOC_SoC_on_Arty_A7-100T.pptx
+++ b/fpga/sw/export/docs/slides/01_EDHOC_SoC_on_Arty_A7-100T.pptx
@@ -10156,7 +10156,7 @@
         </p:nvGraphicFramePr>
         <p:xfrm>
           <a:off x="365760" y="868680"/>
-          <a:ext cx="11430000" cy="4206240"/>
+          <a:ext cx="11430000" cy="3657600"/>
         </p:xfrm>
         <a:graphic>
           <a:graphicData uri="http://schemas.openxmlformats.org/drawingml/2006/table">
@@ -10169,14 +10169,14 @@
                 <a:gridCol w="2194560"/>
                 <a:gridCol w="4114800"/>
               </a:tblGrid>
-              <a:tr h="467360">
+              <a:tr h="406400">
                 <a:tc>
                   <a:txBody>
                     <a:bodyPr wrap="square"/>
                     <a:lstStyle/>
                     <a:p>
                       <a:r>
-                        <a:rPr sz="1500" b="1">
+                        <a:rPr sz="1400" b="1">
                           <a:solidFill>
                             <a:srgbClr val="000000"/>
                           </a:solidFill>
@@ -10198,7 +10198,7 @@
                     <a:lstStyle/>
                     <a:p>
                       <a:r>
-                        <a:rPr sz="1500" b="1">
+                        <a:rPr sz="1400" b="1">
                           <a:solidFill>
                             <a:srgbClr val="000000"/>
                           </a:solidFill>
@@ -10220,7 +10220,7 @@
                     <a:lstStyle/>
                     <a:p>
                       <a:r>
-                        <a:rPr sz="1500" b="1">
+                        <a:rPr sz="1400" b="1">
                           <a:solidFill>
                             <a:srgbClr val="000000"/>
                           </a:solidFill>
@@ -10237,14 +10237,14 @@
                   </a:tcPr>
                 </a:tc>
               </a:tr>
-              <a:tr h="467360">
+              <a:tr h="406400">
                 <a:tc>
                   <a:txBody>
                     <a:bodyPr wrap="square"/>
                     <a:lstStyle/>
                     <a:p>
                       <a:r>
-                        <a:rPr sz="1500" b="0">
+                        <a:rPr sz="1400" b="0">
                           <a:solidFill>
                             <a:srgbClr val="000000"/>
                           </a:solidFill>
@@ -10266,7 +10266,7 @@
                     <a:lstStyle/>
                     <a:p>
                       <a:r>
-                        <a:rPr sz="1500" b="0">
+                        <a:rPr sz="1400" b="0">
                           <a:solidFill>
                             <a:srgbClr val="000000"/>
                           </a:solidFill>
@@ -10288,7 +10288,7 @@
                     <a:lstStyle/>
                     <a:p>
                       <a:r>
-                        <a:rPr sz="1500" b="0">
+                        <a:rPr sz="1400" b="0">
                           <a:solidFill>
                             <a:srgbClr val="000000"/>
                           </a:solidFill>
@@ -10305,14 +10305,14 @@
                   </a:tcPr>
                 </a:tc>
               </a:tr>
-              <a:tr h="467360">
+              <a:tr h="406400">
                 <a:tc>
                   <a:txBody>
                     <a:bodyPr wrap="square"/>
                     <a:lstStyle/>
                     <a:p>
                       <a:r>
-                        <a:rPr sz="1500" b="0">
+                        <a:rPr sz="1400" b="0">
                           <a:solidFill>
                             <a:srgbClr val="000000"/>
                           </a:solidFill>
@@ -10334,7 +10334,7 @@
                     <a:lstStyle/>
                     <a:p>
                       <a:r>
-                        <a:rPr sz="1500" b="0">
+                        <a:rPr sz="1400" b="0">
                           <a:solidFill>
                             <a:srgbClr val="000000"/>
                           </a:solidFill>
@@ -10356,7 +10356,7 @@
                     <a:lstStyle/>
                     <a:p>
                       <a:r>
-                        <a:rPr sz="1500" b="0">
+                        <a:rPr sz="1400" b="0">
                           <a:solidFill>
                             <a:srgbClr val="000000"/>
                           </a:solidFill>
@@ -10373,14 +10373,14 @@
                   </a:tcPr>
                 </a:tc>
               </a:tr>
-              <a:tr h="467360">
+              <a:tr h="406400">
                 <a:tc>
                   <a:txBody>
                     <a:bodyPr wrap="square"/>
                     <a:lstStyle/>
                     <a:p>
                       <a:r>
-                        <a:rPr sz="1500" b="0">
+                        <a:rPr sz="1400" b="0">
                           <a:solidFill>
                             <a:srgbClr val="000000"/>
                           </a:solidFill>
@@ -10402,7 +10402,7 @@
                     <a:lstStyle/>
                     <a:p>
                       <a:r>
-                        <a:rPr sz="1500" b="0">
+                        <a:rPr sz="1400" b="0">
                           <a:solidFill>
                             <a:srgbClr val="000000"/>
                           </a:solidFill>
@@ -10424,7 +10424,7 @@
                     <a:lstStyle/>
                     <a:p>
                       <a:r>
-                        <a:rPr sz="1500" b="0">
+                        <a:rPr sz="1400" b="0">
                           <a:solidFill>
                             <a:srgbClr val="000000"/>
                           </a:solidFill>
@@ -10441,14 +10441,14 @@
                   </a:tcPr>
                 </a:tc>
               </a:tr>
-              <a:tr h="467360">
+              <a:tr h="406400">
                 <a:tc>
                   <a:txBody>
                     <a:bodyPr wrap="square"/>
                     <a:lstStyle/>
                     <a:p>
                       <a:r>
-                        <a:rPr sz="1500" b="0">
+                        <a:rPr sz="1400" b="0">
                           <a:solidFill>
                             <a:srgbClr val="000000"/>
                           </a:solidFill>
@@ -10470,7 +10470,7 @@
                     <a:lstStyle/>
                     <a:p>
                       <a:r>
-                        <a:rPr sz="1500" b="0">
+                        <a:rPr sz="1400" b="0">
                           <a:solidFill>
                             <a:srgbClr val="000000"/>
                           </a:solidFill>
@@ -10492,7 +10492,7 @@
                     <a:lstStyle/>
                     <a:p>
                       <a:r>
-                        <a:rPr sz="1500" b="0">
+                        <a:rPr sz="1400" b="0">
                           <a:solidFill>
                             <a:srgbClr val="000000"/>
                           </a:solidFill>
@@ -10509,14 +10509,14 @@
                   </a:tcPr>
                 </a:tc>
               </a:tr>
-              <a:tr h="467360">
+              <a:tr h="406400">
                 <a:tc>
                   <a:txBody>
                     <a:bodyPr wrap="square"/>
                     <a:lstStyle/>
                     <a:p>
                       <a:r>
-                        <a:rPr sz="1500" b="0">
+                        <a:rPr sz="1400" b="0">
                           <a:solidFill>
                             <a:srgbClr val="000000"/>
                           </a:solidFill>
@@ -10538,7 +10538,7 @@
                     <a:lstStyle/>
                     <a:p>
                       <a:r>
-                        <a:rPr sz="1500" b="0">
+                        <a:rPr sz="1400" b="0">
                           <a:solidFill>
                             <a:srgbClr val="000000"/>
                           </a:solidFill>
@@ -10560,7 +10560,7 @@
                     <a:lstStyle/>
                     <a:p>
                       <a:r>
-                        <a:rPr sz="1500" b="0">
+                        <a:rPr sz="1400" b="0">
                           <a:solidFill>
                             <a:srgbClr val="000000"/>
                           </a:solidFill>
@@ -10577,20 +10577,20 @@
                   </a:tcPr>
                 </a:tc>
               </a:tr>
-              <a:tr h="467360">
+              <a:tr h="406400">
                 <a:tc>
                   <a:txBody>
                     <a:bodyPr wrap="square"/>
                     <a:lstStyle/>
                     <a:p>
                       <a:r>
-                        <a:rPr sz="1500" b="0">
+                        <a:rPr sz="1400" b="0">
                           <a:solidFill>
                             <a:srgbClr val="000000"/>
                           </a:solidFill>
                           <a:latin typeface="Times New Roman"/>
                         </a:rPr>
-                        <a:t>Python 3</a:t>
+                        <a:t>Python 3 (in a venv, command below)</a:t>
                       </a:r>
                     </a:p>
                   </a:txBody>
@@ -10606,13 +10606,13 @@
                     <a:lstStyle/>
                     <a:p>
                       <a:r>
-                        <a:rPr sz="1500" b="0">
+                        <a:rPr sz="1400" b="0">
                           <a:solidFill>
                             <a:srgbClr val="000000"/>
                           </a:solidFill>
                           <a:latin typeface="Times New Roman"/>
                         </a:rPr>
-                        <a:t>3.11</a:t>
+                        <a:t>3.12</a:t>
                       </a:r>
                     </a:p>
                   </a:txBody>
@@ -10628,7 +10628,7 @@
                     <a:lstStyle/>
                     <a:p>
                       <a:r>
-                        <a:rPr sz="1500" b="0">
+                        <a:rPr sz="1400" b="0">
                           <a:solidFill>
                             <a:srgbClr val="000000"/>
                           </a:solidFill>
@@ -10645,20 +10645,20 @@
                   </a:tcPr>
                 </a:tc>
               </a:tr>
-              <a:tr h="467360">
+              <a:tr h="406400">
                 <a:tc>
                   <a:txBody>
                     <a:bodyPr wrap="square"/>
                     <a:lstStyle/>
                     <a:p>
                       <a:r>
-                        <a:rPr sz="1500" b="0">
+                        <a:rPr sz="1400" b="0">
                           <a:solidFill>
                             <a:srgbClr val="000000"/>
                           </a:solidFill>
                           <a:latin typeface="Times New Roman"/>
                         </a:rPr>
-                        <a:t>pip: pyfatfs pycryptodome cryptography kyber-py</a:t>
+                        <a:t>pip: pyfatfs pycryptodome cryptography kyber-py setuptools&lt;81</a:t>
                       </a:r>
                     </a:p>
                   </a:txBody>
@@ -10674,7 +10674,7 @@
                     <a:lstStyle/>
                     <a:p>
                       <a:r>
-                        <a:rPr sz="1500" b="0">
+                        <a:rPr sz="1400" b="0">
                           <a:solidFill>
                             <a:srgbClr val="000000"/>
                           </a:solidFill>
@@ -10696,7 +10696,7 @@
                     <a:lstStyle/>
                     <a:p>
                       <a:r>
-                        <a:rPr sz="1500" b="0">
+                        <a:rPr sz="1400" b="0">
                           <a:solidFill>
                             <a:srgbClr val="000000"/>
                           </a:solidFill>
@@ -10713,14 +10713,14 @@
                   </a:tcPr>
                 </a:tc>
               </a:tr>
-              <a:tr h="467360">
+              <a:tr h="406400">
                 <a:tc>
                   <a:txBody>
                     <a:bodyPr wrap="square"/>
                     <a:lstStyle/>
                     <a:p>
                       <a:r>
-                        <a:rPr sz="1500" b="0">
+                        <a:rPr sz="1400" b="0">
                           <a:solidFill>
                             <a:srgbClr val="000000"/>
                           </a:solidFill>
@@ -10742,7 +10742,7 @@
                     <a:lstStyle/>
                     <a:p>
                       <a:r>
-                        <a:rPr sz="1500" b="0">
+                        <a:rPr sz="1400" b="0">
                           <a:solidFill>
                             <a:srgbClr val="000000"/>
                           </a:solidFill>
@@ -10764,7 +10764,7 @@
                     <a:lstStyle/>
                     <a:p>
                       <a:r>
-                        <a:rPr sz="1500" b="0">
+                        <a:rPr sz="1400" b="0">
                           <a:solidFill>
                             <a:srgbClr val="000000"/>
                           </a:solidFill>
@@ -10787,14 +10787,101 @@
       </p:graphicFrame>
       <p:sp>
         <p:nvSpPr>
-          <p:cNvPr id="64" name="TextBox 63"/>
+          <p:cNvPr id="64" name="Rectangle 63"/>
+          <p:cNvSpPr/>
+          <p:nvPr/>
+        </p:nvSpPr>
+        <p:spPr>
+          <a:xfrm>
+            <a:off x="365760" y="4617720"/>
+            <a:ext cx="11430000" cy="805433"/>
+          </a:xfrm>
+          <a:prstGeom prst="rect">
+            <a:avLst/>
+          </a:prstGeom>
+          <a:solidFill>
+            <a:srgbClr val="F4F4F4"/>
+          </a:solidFill>
+          <a:ln>
+            <a:solidFill>
+              <a:srgbClr val="C8C8C8"/>
+            </a:solidFill>
+          </a:ln>
+          <a:effectLst/>
+        </p:spPr>
+        <p:style>
+          <a:lnRef idx="1">
+            <a:schemeClr val="accent1"/>
+          </a:lnRef>
+          <a:fillRef idx="3">
+            <a:schemeClr val="accent1"/>
+          </a:fillRef>
+          <a:effectRef idx="2">
+            <a:schemeClr val="accent1"/>
+          </a:effectRef>
+          <a:fontRef idx="minor">
+            <a:schemeClr val="lt1"/>
+          </a:fontRef>
+        </p:style>
+        <p:txBody>
+          <a:bodyPr rtlCol="0" anchor="t" wrap="none" lIns="73152" rIns="73152" tIns="73152" bIns="73152"/>
+          <a:lstStyle/>
+          <a:p>
+            <a:pPr algn="l"/>
+            <a:r>
+              <a:rPr sz="1300" b="1">
+                <a:solidFill>
+                  <a:srgbClr val="808080"/>
+                </a:solidFill>
+                <a:latin typeface="Consolas"/>
+              </a:rPr>
+              <a:t>Run this — once; plain pip install is refused on Ubuntu 24.04</a:t>
+            </a:r>
+          </a:p>
+          <a:p>
+            <a:pPr algn="l">
+              <a:lnSpc>
+                <a:spcPct val="100000"/>
+              </a:lnSpc>
+            </a:pPr>
+            <a:r>
+              <a:rPr sz="1300">
+                <a:solidFill>
+                  <a:srgbClr val="1F1F1F"/>
+                </a:solidFill>
+                <a:latin typeface="Consolas"/>
+              </a:rPr>
+              <a:t>python3 -m venv ~/edhoc-venv &amp;&amp; . ~/edhoc-venv/bin/activate</a:t>
+            </a:r>
+          </a:p>
+          <a:p>
+            <a:pPr algn="l">
+              <a:lnSpc>
+                <a:spcPct val="100000"/>
+              </a:lnSpc>
+            </a:pPr>
+            <a:r>
+              <a:rPr sz="1300">
+                <a:solidFill>
+                  <a:srgbClr val="1F1F1F"/>
+                </a:solidFill>
+                <a:latin typeface="Consolas"/>
+              </a:rPr>
+              <a:t>pip install pyfatfs pycryptodome cryptography kyber-py "setuptools&lt;81"</a:t>
+            </a:r>
+          </a:p>
+        </p:txBody>
+      </p:sp>
+      <p:sp>
+        <p:nvSpPr>
+          <p:cNvPr id="65" name="TextBox 64"/>
           <p:cNvSpPr txBox="1"/>
           <p:nvPr/>
         </p:nvSpPr>
         <p:spPr>
           <a:xfrm>
-            <a:off x="365760" y="5257800"/>
-            <a:ext cx="11430000" cy="1188720"/>
+            <a:off x="365760" y="5486400"/>
+            <a:ext cx="11430000" cy="1005840"/>
           </a:xfrm>
           <a:prstGeom prst="rect">
             <a:avLst/>
@@ -10814,7 +10901,7 @@
               <a:buChar char="•"/>
             </a:pPr>
             <a:r>
-              <a:rPr sz="1600" b="0">
+              <a:rPr sz="1400" b="0">
                 <a:solidFill>
                   <a:srgbClr val="000000"/>
                 </a:solidFill>
@@ -10823,7 +10910,7 @@
               <a:t>USB access without sudo: install Vivado's cable drivers (Digilent) and OpenOCD's </a:t>
             </a:r>
             <a:r>
-              <a:rPr sz="1600" b="0" i="1">
+              <a:rPr sz="1400" b="0" i="1">
                 <a:solidFill>
                   <a:srgbClr val="000000"/>
                 </a:solidFill>
@@ -10832,7 +10919,7 @@
               <a:t>60-openocd.rules</a:t>
             </a:r>
             <a:r>
-              <a:rPr sz="1600" b="0">
+              <a:rPr sz="1400" b="0">
                 <a:solidFill>
                   <a:srgbClr val="000000"/>
                 </a:solidFill>
@@ -10841,7 +10928,7 @@
               <a:t> (C232HM), and be in the </a:t>
             </a:r>
             <a:r>
-              <a:rPr sz="1600" b="0" i="1">
+              <a:rPr sz="1400" b="0" i="1">
                 <a:solidFill>
                   <a:srgbClr val="000000"/>
                 </a:solidFill>
@@ -10850,7 +10937,7 @@
               <a:t>dialout</a:t>
             </a:r>
             <a:r>
-              <a:rPr sz="1600" b="0">
+              <a:rPr sz="1400" b="0">
                 <a:solidFill>
                   <a:srgbClr val="000000"/>
                 </a:solidFill>
@@ -10859,7 +10946,7 @@
               <a:t> / </a:t>
             </a:r>
             <a:r>
-              <a:rPr sz="1600" b="0" i="1">
+              <a:rPr sz="1400" b="0" i="1">
                 <a:solidFill>
                   <a:srgbClr val="000000"/>
                 </a:solidFill>
@@ -10868,7 +10955,7 @@
               <a:t>plugdev</a:t>
             </a:r>
             <a:r>
-              <a:rPr sz="1600" b="0">
+              <a:rPr sz="1400" b="0">
                 <a:solidFill>
                   <a:srgbClr val="000000"/>
                 </a:solidFill>
@@ -10885,7 +10972,7 @@
               <a:buChar char="•"/>
             </a:pPr>
             <a:r>
-              <a:rPr sz="1600" b="0">
+              <a:rPr sz="1400" b="0">
                 <a:solidFill>
                   <a:srgbClr val="000000"/>
                 </a:solidFill>
@@ -11111,7 +11198,7 @@
                 </a:solidFill>
                 <a:latin typeface="Consolas"/>
               </a:rPr>
-              <a:t>git clone git@github.com:Khaiduy/chipyard-edhoc.git chipyard</a:t>
+              <a:t>git clone git@github.com:Khaiduy/chipyard-edhoc.git chipyard   # path without spaces</a:t>
             </a:r>
           </a:p>
           <a:p>
@@ -11303,7 +11390,7 @@
                           </a:solidFill>
                           <a:latin typeface="Times New Roman"/>
                         </a:rPr>
-                        <a:t>./build-setup.sh riscv-tools; source env.sh; ./scripts/init-fpga.sh; ./patches/apply.sh</a:t>
+                        <a:t>./build-setup.sh riscv-tools --skip-marshal --skip-firesim; source env.sh; ./patches/apply.sh (~30 min, ~20 GB + Vivado; then ~1 h per bitstream)</a:t>
                       </a:r>
                     </a:p>
                   </a:txBody>
@@ -11438,8 +11525,8 @@
         </p:nvSpPr>
         <p:spPr>
           <a:xfrm>
-            <a:off x="365760" y="4206240"/>
-            <a:ext cx="11430000" cy="2103120"/>
+            <a:off x="365760" y="4663440"/>
+            <a:ext cx="11430000" cy="1828800"/>
           </a:xfrm>
           <a:prstGeom prst="rect">
             <a:avLst/>
@@ -11459,7 +11546,7 @@
               <a:buChar char="•"/>
             </a:pPr>
             <a:r>
-              <a:rPr sz="1700" b="0">
+              <a:rPr sz="1600" b="0">
                 <a:solidFill>
                   <a:srgbClr val="000000"/>
                 </a:solidFill>
@@ -11468,7 +11555,7 @@
               <a:t>The repository is </a:t>
             </a:r>
             <a:r>
-              <a:rPr sz="1700" b="1">
+              <a:rPr sz="1600" b="1">
                 <a:solidFill>
                   <a:srgbClr val="000000"/>
                 </a:solidFill>
@@ -11477,7 +11564,7 @@
               <a:t>private</a:t>
             </a:r>
             <a:r>
-              <a:rPr sz="1700" b="0">
+              <a:rPr sz="1600" b="0">
                 <a:solidFill>
                   <a:srgbClr val="000000"/>
                 </a:solidFill>
@@ -11494,7 +11581,7 @@
               <a:buChar char="•"/>
             </a:pPr>
             <a:r>
-              <a:rPr sz="1700" b="0">
+              <a:rPr sz="1600" b="0">
                 <a:solidFill>
                   <a:srgbClr val="000000"/>
                 </a:solidFill>
@@ -11503,7 +11590,7 @@
               <a:t>No prebuilt bitstream ships with the course: route B needs a bitstream built from the </a:t>
             </a:r>
             <a:r>
-              <a:rPr sz="1700" b="1">
+              <a:rPr sz="1600" b="1">
                 <a:solidFill>
                   <a:srgbClr val="000000"/>
                 </a:solidFill>
@@ -11512,7 +11599,7 @@
               <a:t>same revision</a:t>
             </a:r>
             <a:r>
-              <a:rPr sz="1700" b="0">
+              <a:rPr sz="1600" b="0">
                 <a:solidFill>
                   <a:srgbClr val="000000"/>
                 </a:solidFill>
@@ -11521,7 +11608,7 @@
               <a:t> (route A), e.g. by your lab, written to the boards' flash or kept as a </a:t>
             </a:r>
             <a:r>
-              <a:rPr sz="1700" b="0" i="1">
+              <a:rPr sz="1600" b="0" i="1">
                 <a:solidFill>
                   <a:srgbClr val="000000"/>
                 </a:solidFill>
@@ -11530,7 +11617,7 @@
               <a:t>.bit</a:t>
             </a:r>
             <a:r>
-              <a:rPr sz="1700" b="0">
+              <a:rPr sz="1600" b="0">
                 <a:solidFill>
                   <a:srgbClr val="000000"/>
                 </a:solidFill>
@@ -11547,7 +11634,7 @@
               <a:buChar char="•"/>
             </a:pPr>
             <a:r>
-              <a:rPr sz="1700" b="0">
+              <a:rPr sz="1600" b="0">
                 <a:solidFill>
                   <a:srgbClr val="000000"/>
                 </a:solidFill>
@@ -11556,7 +11643,7 @@
               <a:t>The firmware tree </a:t>
             </a:r>
             <a:r>
-              <a:rPr sz="1700" b="0" i="1">
+              <a:rPr sz="1600" b="0" i="1">
                 <a:solidFill>
                   <a:srgbClr val="000000"/>
                 </a:solidFill>
@@ -11565,7 +11652,7 @@
               <a:t>fpga/sw/export/</a:t>
             </a:r>
             <a:r>
-              <a:rPr sz="1700" b="0">
+              <a:rPr sz="1600" b="0">
                 <a:solidFill>
                   <a:srgbClr val="000000"/>
                 </a:solidFill>
@@ -12035,6 +12122,32 @@
                 <a:latin typeface="Times New Roman"/>
               </a:rPr>
               <a:t> C232HM lines.</a:t>
+            </a:r>
+          </a:p>
+          <a:p>
+            <a:pPr marL="256032" indent="-219456">
+              <a:spcAft>
+                <a:spcPts val="400"/>
+              </a:spcAft>
+              <a:buChar char="•"/>
+            </a:pPr>
+            <a:r>
+              <a:rPr sz="1600" b="0" i="1">
+                <a:solidFill>
+                  <a:srgbClr val="000000"/>
+                </a:solidFill>
+                <a:latin typeface="Times New Roman"/>
+              </a:rPr>
+              <a:t>common/board/boards.env</a:t>
+            </a:r>
+            <a:r>
+              <a:rPr sz="1600" b="0">
+                <a:solidFill>
+                  <a:srgbClr val="000000"/>
+                </a:solidFill>
+                <a:latin typeface="Times New Roman"/>
+              </a:rPr>
+              <a:t> ships with our serials: put your four in (Lesson 2, section 2).</a:t>
             </a:r>
           </a:p>
         </p:txBody>
@@ -36081,7 +36194,7 @@
                 </a:solidFill>
                 <a:latin typeface="Times New Roman"/>
               </a:rPr>
-              <a:t>; Lesson 2 shows how to fill it in with your serials.</a:t>
+              <a:t>. It ships with our serials: put yours in first (Lesson 2, section 2, (1/3)–(2/3)).</a:t>
             </a:r>
           </a:p>
           <a:p>

</xml_diff>

<commit_message>
docs: note the harmless 'Error 1 (ignored)' make lines
</commit_message>
<xml_diff>
--- a/fpga/sw/export/docs/slides/01_EDHOC_SoC_on_Arty_A7-100T.pptx
+++ b/fpga/sw/export/docs/slides/01_EDHOC_SoC_on_Arty_A7-100T.pptx
@@ -31939,7 +31939,7 @@
               <a:buChar char="•"/>
             </a:pPr>
             <a:r>
-              <a:rPr sz="1800" b="0">
+              <a:rPr sz="1600" b="0">
                 <a:solidFill>
                   <a:srgbClr val="000000"/>
                 </a:solidFill>
@@ -31948,7 +31948,7 @@
               <a:t>Output folder: </a:t>
             </a:r>
             <a:r>
-              <a:rPr sz="1800" b="0" i="1">
+              <a:rPr sz="1600" b="0" i="1">
                 <a:solidFill>
                   <a:srgbClr val="000000"/>
                 </a:solidFill>
@@ -31965,7 +31965,7 @@
               <a:buChar char="–"/>
             </a:pPr>
             <a:r>
-              <a:rPr sz="1600" b="0" i="1">
+              <a:rPr sz="1400" b="0" i="1">
                 <a:solidFill>
                   <a:srgbClr val="000000"/>
                 </a:solidFill>
@@ -31974,7 +31974,7 @@
               <a:t>Arty100TWithoutDDRHarness.bit</a:t>
             </a:r>
             <a:r>
-              <a:rPr sz="1600" b="0">
+              <a:rPr sz="1400" b="0">
                 <a:solidFill>
                   <a:srgbClr val="000000"/>
                 </a:solidFill>
@@ -31991,7 +31991,7 @@
               <a:buChar char="–"/>
             </a:pPr>
             <a:r>
-              <a:rPr sz="1600" b="0" i="1">
+              <a:rPr sz="1400" b="0" i="1">
                 <a:solidFill>
                   <a:srgbClr val="000000"/>
                 </a:solidFill>
@@ -32000,7 +32000,7 @@
               <a:t>report/timing.txt</a:t>
             </a:r>
             <a:r>
-              <a:rPr sz="1600" b="0">
+              <a:rPr sz="1400" b="0">
                 <a:solidFill>
                   <a:srgbClr val="000000"/>
                 </a:solidFill>
@@ -32009,7 +32009,7 @@
               <a:t>, </a:t>
             </a:r>
             <a:r>
-              <a:rPr sz="1600" b="0" i="1">
+              <a:rPr sz="1400" b="0" i="1">
                 <a:solidFill>
                   <a:srgbClr val="000000"/>
                 </a:solidFill>
@@ -32018,7 +32018,7 @@
               <a:t>report/utilization.txt</a:t>
             </a:r>
             <a:r>
-              <a:rPr sz="1600" b="0">
+              <a:rPr sz="1400" b="0">
                 <a:solidFill>
                   <a:srgbClr val="000000"/>
                 </a:solidFill>
@@ -32035,7 +32035,7 @@
               <a:buChar char="–"/>
             </a:pPr>
             <a:r>
-              <a:rPr sz="1600" b="0" i="1">
+              <a:rPr sz="1400" b="0" i="1">
                 <a:solidFill>
                   <a:srgbClr val="000000"/>
                 </a:solidFill>
@@ -32044,7 +32044,7 @@
               <a:t>post_opt.dcp</a:t>
             </a:r>
             <a:r>
-              <a:rPr sz="1600" b="0">
+              <a:rPr sz="1400" b="0">
                 <a:solidFill>
                   <a:srgbClr val="000000"/>
                 </a:solidFill>
@@ -32053,7 +32053,7 @@
               <a:t>, </a:t>
             </a:r>
             <a:r>
-              <a:rPr sz="1600" b="0" i="1">
+              <a:rPr sz="1400" b="0" i="1">
                 <a:solidFill>
                   <a:srgbClr val="000000"/>
                 </a:solidFill>
@@ -32062,7 +32062,7 @@
               <a:t>post_route.dcp</a:t>
             </a:r>
             <a:r>
-              <a:rPr sz="1600" b="0">
+              <a:rPr sz="1400" b="0">
                 <a:solidFill>
                   <a:srgbClr val="000000"/>
                 </a:solidFill>
@@ -32079,7 +32079,7 @@
               <a:buChar char="•"/>
             </a:pPr>
             <a:r>
-              <a:rPr sz="1800" b="1">
+              <a:rPr sz="1600" b="1">
                 <a:solidFill>
                   <a:srgbClr val="000000"/>
                 </a:solidFill>
@@ -32088,7 +32088,7 @@
               <a:t>Careful:</a:t>
             </a:r>
             <a:r>
-              <a:rPr sz="1800" b="0">
+              <a:rPr sz="1600" b="0">
                 <a:solidFill>
                   <a:srgbClr val="000000"/>
                 </a:solidFill>
@@ -32097,7 +32097,7 @@
               <a:t> exit status 0 does not mean timing was met, and a failed flow may still leave a </a:t>
             </a:r>
             <a:r>
-              <a:rPr sz="1800" b="0" i="1">
+              <a:rPr sz="1600" b="0" i="1">
                 <a:solidFill>
                   <a:srgbClr val="000000"/>
                 </a:solidFill>
@@ -32106,7 +32106,7 @@
               <a:t>.bit</a:t>
             </a:r>
             <a:r>
-              <a:rPr sz="1800" b="0">
+              <a:rPr sz="1600" b="0">
                 <a:solidFill>
                   <a:srgbClr val="000000"/>
                 </a:solidFill>
@@ -32115,7 +32115,7 @@
               <a:t>. Timing is decided only by </a:t>
             </a:r>
             <a:r>
-              <a:rPr sz="1800" b="0" i="1">
+              <a:rPr sz="1600" b="0" i="1">
                 <a:solidFill>
                   <a:srgbClr val="000000"/>
                 </a:solidFill>
@@ -32124,13 +32124,48 @@
               <a:t>report/timing.txt</a:t>
             </a:r>
             <a:r>
-              <a:rPr sz="1800" b="0">
+              <a:rPr sz="1600" b="0">
                 <a:solidFill>
                   <a:srgbClr val="000000"/>
                 </a:solidFill>
                 <a:latin typeface="Times New Roman"/>
               </a:rPr>
               <a:t>: read it before using a new bitstream.</a:t>
+            </a:r>
+          </a:p>
+          <a:p>
+            <a:pPr marL="256032" indent="-219456">
+              <a:spcAft>
+                <a:spcPts val="400"/>
+              </a:spcAft>
+              <a:buChar char="•"/>
+            </a:pPr>
+            <a:r>
+              <a:rPr sz="1600" b="0">
+                <a:solidFill>
+                  <a:srgbClr val="000000"/>
+                </a:solidFill>
+                <a:latin typeface="Times New Roman"/>
+              </a:rPr>
+              <a:t>Lines like </a:t>
+            </a:r>
+            <a:r>
+              <a:rPr sz="1400" b="0">
+                <a:solidFill>
+                  <a:srgbClr val="8B1A1A"/>
+                </a:solidFill>
+                <a:latin typeface="Consolas"/>
+              </a:rPr>
+              <a:t>make: [...] Error 1 (ignored)</a:t>
+            </a:r>
+            <a:r>
+              <a:rPr sz="1600" b="0">
+                <a:solidFill>
+                  <a:srgbClr val="000000"/>
+                </a:solidFill>
+                <a:latin typeface="Times New Roman"/>
+              </a:rPr>
+              <a:t> are normal: a Chipyard copy step that has no files to copy in the FPGA flow.</a:t>
             </a:r>
           </a:p>
         </p:txBody>

</xml_diff>

<commit_message>
docs: topic titles instead of 'If ...' titles in slides and README
</commit_message>
<xml_diff>
--- a/fpga/sw/export/docs/slides/01_EDHOC_SoC_on_Arty_A7-100T.pptx
+++ b/fpga/sw/export/docs/slides/01_EDHOC_SoC_on_Arty_A7-100T.pptx
@@ -10594,7 +10594,7 @@
                           </a:solidFill>
                           <a:latin typeface="Times New Roman"/>
                         </a:rPr>
-                        <a:t>Python 3 (in a venv, command below)</a:t>
+                        <a:t>Python 3</a:t>
                       </a:r>
                     </a:p>
                   </a:txBody>
@@ -10824,7 +10824,7 @@
                 </a:solidFill>
                 <a:latin typeface="Times New Roman"/>
               </a:rPr>
-              <a:t>USB access without sudo: install Vivado's cable drivers (Digilent) and OpenOCD's </a:t>
+              <a:t>USB access without sudo: Vivado's cable drivers (6/12), OpenOCD's udev rules (the apt package) and the </a:t>
             </a:r>
             <a:r>
               <a:rPr sz="1500" b="0" i="1">
@@ -10833,7 +10833,7 @@
                 </a:solidFill>
                 <a:latin typeface="Times New Roman"/>
               </a:rPr>
-              <a:t>60-openocd.rules</a:t>
+              <a:t>dialout</a:t>
             </a:r>
             <a:r>
               <a:rPr sz="1500" b="0">
@@ -10842,7 +10842,7 @@
                 </a:solidFill>
                 <a:latin typeface="Times New Roman"/>
               </a:rPr>
-              <a:t> (C232HM), and be in the </a:t>
+              <a:t> / </a:t>
             </a:r>
             <a:r>
               <a:rPr sz="1500" b="0" i="1">
@@ -10851,7 +10851,7 @@
                 </a:solidFill>
                 <a:latin typeface="Times New Roman"/>
               </a:rPr>
-              <a:t>dialout</a:t>
+              <a:t>plugdev</a:t>
             </a:r>
             <a:r>
               <a:rPr sz="1500" b="0">
@@ -10860,25 +10860,7 @@
                 </a:solidFill>
                 <a:latin typeface="Times New Roman"/>
               </a:rPr>
-              <a:t> / </a:t>
-            </a:r>
-            <a:r>
-              <a:rPr sz="1500" b="0" i="1">
-                <a:solidFill>
-                  <a:srgbClr val="000000"/>
-                </a:solidFill>
-                <a:latin typeface="Times New Roman"/>
-              </a:rPr>
-              <a:t>plugdev</a:t>
-            </a:r>
-            <a:r>
-              <a:rPr sz="1500" b="0">
-                <a:solidFill>
-                  <a:srgbClr val="000000"/>
-                </a:solidFill>
-                <a:latin typeface="Times New Roman"/>
-              </a:rPr>
-              <a:t> groups for the consoles.</a:t>
+              <a:t> groups (7/12).</a:t>
             </a:r>
           </a:p>
           <a:p>
@@ -12159,7 +12141,7 @@
         <p:spPr>
           <a:xfrm>
             <a:off x="365760" y="868680"/>
-            <a:ext cx="11430000" cy="3176016"/>
+            <a:ext cx="11430000" cy="3361944"/>
           </a:xfrm>
           <a:prstGeom prst="rect">
             <a:avLst/>
@@ -12280,6 +12262,22 @@
                 </a:solidFill>
                 <a:latin typeface="Consolas"/>
               </a:rPr>
+              <a:t>sudo usermod -aG dialout,plugdev $USER     # board consoles; takes effect after logging in again</a:t>
+            </a:r>
+          </a:p>
+          <a:p>
+            <a:pPr algn="l">
+              <a:lnSpc>
+                <a:spcPct val="100000"/>
+              </a:lnSpc>
+            </a:pPr>
+            <a:r>
+              <a:rPr sz="1200">
+                <a:solidFill>
+                  <a:srgbClr val="1F1F1F"/>
+                </a:solidFill>
+                <a:latin typeface="Consolas"/>
+              </a:rPr>
               <a:t>python3 -m venv ~/edhoc-venv</a:t>
             </a:r>
           </a:p>
@@ -12453,7 +12451,7 @@
         </p:nvSpPr>
         <p:spPr>
           <a:xfrm>
-            <a:off x="365760" y="4227576"/>
+            <a:off x="365760" y="4413504"/>
             <a:ext cx="11430000" cy="1920240"/>
           </a:xfrm>
           <a:prstGeom prst="rect">
@@ -13987,7 +13985,7 @@
                 <a:gridCol w="3017520"/>
                 <a:gridCol w="8412480"/>
               </a:tblGrid>
-              <a:tr h="388620">
+              <a:tr h="310896">
                 <a:tc>
                   <a:txBody>
                     <a:bodyPr wrap="square"/>
@@ -14033,7 +14031,7 @@
                   </a:tcPr>
                 </a:tc>
               </a:tr>
-              <a:tr h="388620">
+              <a:tr h="310896">
                 <a:tc>
                   <a:txBody>
                     <a:bodyPr wrap="square"/>
@@ -14046,7 +14044,7 @@
                           </a:solidFill>
                           <a:latin typeface="Times New Roman"/>
                         </a:rPr>
-                        <a:t>an Arty is missing</a:t>
+                        <a:t>MISSING: &lt;tool&gt;</a:t>
                       </a:r>
                     </a:p>
                   </a:txBody>
@@ -14068,7 +14066,7 @@
                           </a:solidFill>
                           <a:latin typeface="Times New Roman"/>
                         </a:rPr>
-                        <a:t>USB cable, board power switch, Vivado cable drivers</a:t>
+                        <a:t>redo that tool's slide ((6/12), (7/12) or (9/12)), then open a new terminal</a:t>
                       </a:r>
                     </a:p>
                   </a:txBody>
@@ -14079,7 +14077,7 @@
                   </a:tcPr>
                 </a:tc>
               </a:tr>
-              <a:tr h="388620">
+              <a:tr h="310896">
                 <a:tc>
                   <a:txBody>
                     <a:bodyPr wrap="square"/>
@@ -14092,7 +14090,7 @@
                           </a:solidFill>
                           <a:latin typeface="Times New Roman"/>
                         </a:rPr>
-                        <a:t>an Arty has no tty</a:t>
+                        <a:t>an Arty is missing</a:t>
                       </a:r>
                     </a:p>
                   </a:txBody>
@@ -14114,7 +14112,7 @@
                           </a:solidFill>
                           <a:latin typeface="Times New Roman"/>
                         </a:rPr>
-                        <a:t>dialout / plugdev group (log out and in), Vivado holding the port</a:t>
+                        <a:t>USB cable, board power switch, Vivado cable drivers</a:t>
                       </a:r>
                     </a:p>
                   </a:txBody>
@@ -14125,7 +14123,7 @@
                   </a:tcPr>
                 </a:tc>
               </a:tr>
-              <a:tr h="388620">
+              <a:tr h="310896">
                 <a:tc>
                   <a:txBody>
                     <a:bodyPr wrap="square"/>
@@ -14138,7 +14136,7 @@
                           </a:solidFill>
                           <a:latin typeface="Times New Roman"/>
                         </a:rPr>
-                        <a:t>a C232HM is missing</a:t>
+                        <a:t>an Arty has no tty</a:t>
                       </a:r>
                     </a:p>
                   </a:txBody>
@@ -14160,13 +14158,59 @@
                           </a:solidFill>
                           <a:latin typeface="Times New Roman"/>
                         </a:rPr>
+                        <a:t>dialout / plugdev group (log out and in), Vivado holding the port</a:t>
+                      </a:r>
+                    </a:p>
+                  </a:txBody>
+                  <a:tcPr marL="54864" marR="54864" marT="27432" marB="27432">
+                    <a:solidFill>
+                      <a:srgbClr val="FFFFFF"/>
+                    </a:solidFill>
+                  </a:tcPr>
+                </a:tc>
+              </a:tr>
+              <a:tr h="310896">
+                <a:tc>
+                  <a:txBody>
+                    <a:bodyPr wrap="square"/>
+                    <a:lstStyle/>
+                    <a:p>
+                      <a:r>
+                        <a:rPr sz="1500" b="0">
+                          <a:solidFill>
+                            <a:srgbClr val="000000"/>
+                          </a:solidFill>
+                          <a:latin typeface="Times New Roman"/>
+                        </a:rPr>
+                        <a:t>a C232HM is missing</a:t>
+                      </a:r>
+                    </a:p>
+                  </a:txBody>
+                  <a:tcPr marL="54864" marR="54864" marT="27432" marB="27432">
+                    <a:solidFill>
+                      <a:srgbClr val="F2F8EE"/>
+                    </a:solidFill>
+                  </a:tcPr>
+                </a:tc>
+                <a:tc>
+                  <a:txBody>
+                    <a:bodyPr wrap="square"/>
+                    <a:lstStyle/>
+                    <a:p>
+                      <a:r>
+                        <a:rPr sz="1500" b="0">
+                          <a:solidFill>
+                            <a:srgbClr val="000000"/>
+                          </a:solidFill>
+                          <a:latin typeface="Times New Roman"/>
+                        </a:rPr>
                         <a:t>USB plug, OpenOCD udev rules (0403:6014)</a:t>
                       </a:r>
                     </a:p>
                   </a:txBody>
                   <a:tcPr marL="54864" marR="54864" marT="27432" marB="27432">
                     <a:solidFill>
-                      <a:srgbClr val="FFFFFF"/>
+                      <a:srgbClr val="F2F8EE"/>
                     </a:solidFill>
                   </a:tcPr>
                 </a:tc>
@@ -35356,18 +35400,18 @@
               </a:buClr>
             </a:pPr>
             <a:r>
-              <a:rPr lang="en-US" sz="2400" b="1" spc="-1" dirty="0">
+              <a:rPr lang="en-US" sz="3200" b="1" spc="-1" dirty="0">
                 <a:latin typeface="Times New Roman" panose="02020603050405020304" pitchFamily="18" charset="0"/>
                 <a:cs typeface="Times New Roman" panose="02020603050405020304" pitchFamily="18" charset="0"/>
               </a:rPr>
               <a:t>5. Build &amp; Timing Closure </a:t>
             </a:r>
             <a:r>
-              <a:rPr lang="en-US" sz="2400" spc="-1" dirty="0">
+              <a:rPr lang="en-US" sz="3200" spc="-1" dirty="0">
                 <a:latin typeface="Times New Roman" panose="02020603050405020304" pitchFamily="18" charset="0"/>
                 <a:cs typeface="Times New Roman" panose="02020603050405020304" pitchFamily="18" charset="0"/>
               </a:rPr>
-              <a:t>(4/5) If WNS is negative or Vivado crashes: the closure recipe</a:t>
+              <a:t>(4/5) The timing closure recipe</a:t>
             </a:r>
           </a:p>
         </p:txBody>

</xml_diff>